<commit_message>
Update Module 8 slide deck
Co-Authored-By: Claude Opus 5.5 <noreply@anthropic.com>
</commit_message>
<xml_diff>
--- a/Module8_Demo_v1.0/Module8_Prompt_Optimization_DSPy.pptx
+++ b/Module8_Demo_v1.0/Module8_Prompt_Optimization_DSPy.pptx
@@ -5,34 +5,35 @@
     <p:sldMasterId id="2147483648" r:id="rId1"/>
   </p:sldMasterIdLst>
   <p:notesMasterIdLst>
-    <p:notesMasterId r:id="rId27"/>
+    <p:notesMasterId r:id="rId28"/>
   </p:notesMasterIdLst>
   <p:sldIdLst>
     <p:sldId id="256" r:id="rId2"/>
     <p:sldId id="257" r:id="rId3"/>
     <p:sldId id="258" r:id="rId4"/>
-    <p:sldId id="259" r:id="rId5"/>
-    <p:sldId id="260" r:id="rId6"/>
-    <p:sldId id="261" r:id="rId7"/>
-    <p:sldId id="262" r:id="rId8"/>
-    <p:sldId id="263" r:id="rId9"/>
-    <p:sldId id="264" r:id="rId10"/>
-    <p:sldId id="265" r:id="rId11"/>
-    <p:sldId id="266" r:id="rId12"/>
-    <p:sldId id="267" r:id="rId13"/>
-    <p:sldId id="268" r:id="rId14"/>
-    <p:sldId id="269" r:id="rId15"/>
-    <p:sldId id="270" r:id="rId16"/>
-    <p:sldId id="271" r:id="rId17"/>
-    <p:sldId id="272" r:id="rId18"/>
-    <p:sldId id="273" r:id="rId19"/>
-    <p:sldId id="274" r:id="rId20"/>
-    <p:sldId id="275" r:id="rId21"/>
-    <p:sldId id="276" r:id="rId22"/>
-    <p:sldId id="277" r:id="rId23"/>
-    <p:sldId id="278" r:id="rId24"/>
-    <p:sldId id="279" r:id="rId25"/>
-    <p:sldId id="280" r:id="rId26"/>
+    <p:sldId id="281" r:id="rId5"/>
+    <p:sldId id="259" r:id="rId6"/>
+    <p:sldId id="260" r:id="rId7"/>
+    <p:sldId id="261" r:id="rId8"/>
+    <p:sldId id="262" r:id="rId9"/>
+    <p:sldId id="263" r:id="rId10"/>
+    <p:sldId id="264" r:id="rId11"/>
+    <p:sldId id="265" r:id="rId12"/>
+    <p:sldId id="266" r:id="rId13"/>
+    <p:sldId id="267" r:id="rId14"/>
+    <p:sldId id="268" r:id="rId15"/>
+    <p:sldId id="269" r:id="rId16"/>
+    <p:sldId id="270" r:id="rId17"/>
+    <p:sldId id="271" r:id="rId18"/>
+    <p:sldId id="272" r:id="rId19"/>
+    <p:sldId id="273" r:id="rId20"/>
+    <p:sldId id="274" r:id="rId21"/>
+    <p:sldId id="275" r:id="rId22"/>
+    <p:sldId id="276" r:id="rId23"/>
+    <p:sldId id="277" r:id="rId24"/>
+    <p:sldId id="278" r:id="rId25"/>
+    <p:sldId id="279" r:id="rId26"/>
+    <p:sldId id="280" r:id="rId27"/>
   </p:sldIdLst>
   <p:sldSz cx="9144000" cy="5143500" type="screen16x9"/>
   <p:notesSz cx="5143500" cy="9144000"/>
@@ -419,7 +420,7 @@
           <a:p>
             <a:fld id="{F7021451-1387-4CA6-816F-3879F97B5CBC}" type="slidenum">
               <a:rPr lang="en-US"/>
-              <a:t>10</a:t>
+              <a:t>11</a:t>
             </a:fld>
             <a:endParaRPr lang="en-US"/>
           </a:p>
@@ -512,7 +513,7 @@
           <a:p>
             <a:fld id="{F7021451-1387-4CA6-816F-3879F97B5CBC}" type="slidenum">
               <a:rPr lang="en-US"/>
-              <a:t>11</a:t>
+              <a:t>12</a:t>
             </a:fld>
             <a:endParaRPr lang="en-US"/>
           </a:p>
@@ -606,7 +607,7 @@
           <a:p>
             <a:fld id="{F7021451-1387-4CA6-816F-3879F97B5CBC}" type="slidenum">
               <a:rPr lang="en-US"/>
-              <a:t>12</a:t>
+              <a:t>13</a:t>
             </a:fld>
             <a:endParaRPr lang="en-US"/>
           </a:p>
@@ -706,7 +707,7 @@
           <a:p>
             <a:fld id="{F7021451-1387-4CA6-816F-3879F97B5CBC}" type="slidenum">
               <a:rPr lang="en-US"/>
-              <a:t>13</a:t>
+              <a:t>14</a:t>
             </a:fld>
             <a:endParaRPr lang="en-US"/>
           </a:p>
@@ -799,7 +800,7 @@
           <a:p>
             <a:fld id="{F7021451-1387-4CA6-816F-3879F97B5CBC}" type="slidenum">
               <a:rPr lang="en-US"/>
-              <a:t>14</a:t>
+              <a:t>15</a:t>
             </a:fld>
             <a:endParaRPr lang="en-US"/>
           </a:p>
@@ -893,7 +894,7 @@
           <a:p>
             <a:fld id="{F7021451-1387-4CA6-816F-3879F97B5CBC}" type="slidenum">
               <a:rPr lang="en-US"/>
-              <a:t>15</a:t>
+              <a:t>16</a:t>
             </a:fld>
             <a:endParaRPr lang="en-US"/>
           </a:p>
@@ -986,7 +987,7 @@
           <a:p>
             <a:fld id="{F7021451-1387-4CA6-816F-3879F97B5CBC}" type="slidenum">
               <a:rPr lang="en-US"/>
-              <a:t>16</a:t>
+              <a:t>17</a:t>
             </a:fld>
             <a:endParaRPr lang="en-US"/>
           </a:p>
@@ -1076,7 +1077,7 @@
           <a:p>
             <a:fld id="{F7021451-1387-4CA6-816F-3879F97B5CBC}" type="slidenum">
               <a:rPr lang="en-US"/>
-              <a:t>17</a:t>
+              <a:t>18</a:t>
             </a:fld>
             <a:endParaRPr lang="en-US"/>
           </a:p>
@@ -1170,7 +1171,7 @@
           <a:p>
             <a:fld id="{F7021451-1387-4CA6-816F-3879F97B5CBC}" type="slidenum">
               <a:rPr lang="en-US"/>
-              <a:t>18</a:t>
+              <a:t>19</a:t>
             </a:fld>
             <a:endParaRPr lang="en-US"/>
           </a:p>
@@ -1263,7 +1264,7 @@
           <a:p>
             <a:fld id="{F7021451-1387-4CA6-816F-3879F97B5CBC}" type="slidenum">
               <a:rPr lang="en-US"/>
-              <a:t>19</a:t>
+              <a:t>20</a:t>
             </a:fld>
             <a:endParaRPr lang="en-US"/>
           </a:p>
@@ -1447,7 +1448,7 @@
           <a:p>
             <a:fld id="{F7021451-1387-4CA6-816F-3879F97B5CBC}" type="slidenum">
               <a:rPr lang="en-US"/>
-              <a:t>20</a:t>
+              <a:t>21</a:t>
             </a:fld>
             <a:endParaRPr lang="en-US"/>
           </a:p>
@@ -1540,7 +1541,7 @@
           <a:p>
             <a:fld id="{F7021451-1387-4CA6-816F-3879F97B5CBC}" type="slidenum">
               <a:rPr lang="en-US"/>
-              <a:t>21</a:t>
+              <a:t>22</a:t>
             </a:fld>
             <a:endParaRPr lang="en-US"/>
           </a:p>
@@ -1634,7 +1635,7 @@
           <a:p>
             <a:fld id="{F7021451-1387-4CA6-816F-3879F97B5CBC}" type="slidenum">
               <a:rPr lang="en-US"/>
-              <a:t>22</a:t>
+              <a:t>23</a:t>
             </a:fld>
             <a:endParaRPr lang="en-US"/>
           </a:p>
@@ -1724,7 +1725,7 @@
           <a:p>
             <a:fld id="{F7021451-1387-4CA6-816F-3879F97B5CBC}" type="slidenum">
               <a:rPr lang="en-US"/>
-              <a:t>23</a:t>
+              <a:t>24</a:t>
             </a:fld>
             <a:endParaRPr lang="en-US"/>
           </a:p>
@@ -1815,7 +1816,7 @@
           <a:p>
             <a:fld id="{F7021451-1387-4CA6-816F-3879F97B5CBC}" type="slidenum">
               <a:rPr lang="en-US"/>
-              <a:t>24</a:t>
+              <a:t>25</a:t>
             </a:fld>
             <a:endParaRPr lang="en-US"/>
           </a:p>
@@ -1904,7 +1905,7 @@
           <a:p>
             <a:fld id="{F7021451-1387-4CA6-816F-3879F97B5CBC}" type="slidenum">
               <a:rPr lang="en-US"/>
-              <a:t>25</a:t>
+              <a:t>26</a:t>
             </a:fld>
             <a:endParaRPr lang="en-US"/>
           </a:p>
@@ -2091,7 +2092,7 @@
           <a:p>
             <a:fld id="{F7021451-1387-4CA6-816F-3879F97B5CBC}" type="slidenum">
               <a:rPr lang="en-US"/>
-              <a:t>4</a:t>
+              <a:t>5</a:t>
             </a:fld>
             <a:endParaRPr lang="en-US"/>
           </a:p>
@@ -2187,7 +2188,7 @@
           <a:p>
             <a:fld id="{F7021451-1387-4CA6-816F-3879F97B5CBC}" type="slidenum">
               <a:rPr lang="en-US"/>
-              <a:t>5</a:t>
+              <a:t>6</a:t>
             </a:fld>
             <a:endParaRPr lang="en-US"/>
           </a:p>
@@ -2286,7 +2287,7 @@
           <a:p>
             <a:fld id="{F7021451-1387-4CA6-816F-3879F97B5CBC}" type="slidenum">
               <a:rPr lang="en-US"/>
-              <a:t>6</a:t>
+              <a:t>7</a:t>
             </a:fld>
             <a:endParaRPr lang="en-US"/>
           </a:p>
@@ -2377,7 +2378,7 @@
           <a:p>
             <a:fld id="{F7021451-1387-4CA6-816F-3879F97B5CBC}" type="slidenum">
               <a:rPr lang="en-US"/>
-              <a:t>7</a:t>
+              <a:t>8</a:t>
             </a:fld>
             <a:endParaRPr lang="en-US"/>
           </a:p>
@@ -2471,7 +2472,7 @@
           <a:p>
             <a:fld id="{F7021451-1387-4CA6-816F-3879F97B5CBC}" type="slidenum">
               <a:rPr lang="en-US"/>
-              <a:t>8</a:t>
+              <a:t>9</a:t>
             </a:fld>
             <a:endParaRPr lang="en-US"/>
           </a:p>
@@ -2561,7 +2562,7 @@
           <a:p>
             <a:fld id="{F7021451-1387-4CA6-816F-3879F97B5CBC}" type="slidenum">
               <a:rPr lang="en-US"/>
-              <a:t>9</a:t>
+              <a:t>10</a:t>
             </a:fld>
             <a:endParaRPr lang="en-US"/>
           </a:p>
@@ -2732,7 +2733,7 @@
           </a:prstGeom>
           <a:extLst>
             <a:ext uri="{C572A759-6A51-4108-AA02-DFA0A04FC94B}">
-              <ma14:wrappingTextBoxFlag xmlns:ma14="http://schemas.microsoft.com/office/mac/drawingml/2011/main" xmlns="" val="0"/>
+              <ma14:wrappingTextBoxFlag xmlns="" xmlns:ma14="http://schemas.microsoft.com/office/mac/drawingml/2011/main" val="0"/>
             </a:ext>
           </a:extLst>
         </p:spPr>
@@ -2840,7 +2841,7 @@
           </a:prstGeom>
           <a:extLst>
             <a:ext uri="{C572A759-6A51-4108-AA02-DFA0A04FC94B}">
-              <ma14:wrappingTextBoxFlag xmlns:ma14="http://schemas.microsoft.com/office/mac/drawingml/2011/main" xmlns="" val="0"/>
+              <ma14:wrappingTextBoxFlag xmlns="" xmlns:ma14="http://schemas.microsoft.com/office/mac/drawingml/2011/main" val="0"/>
             </a:ext>
           </a:extLst>
         </p:spPr>
@@ -3371,6 +3372,778 @@
 
 <file path=ppt/slides/slide10.xml><?xml version="1.0" encoding="utf-8"?>
 <p:sld xmlns:a="http://schemas.openxmlformats.org/drawingml/2006/main" xmlns:r="http://schemas.openxmlformats.org/officeDocument/2006/relationships" xmlns:p="http://schemas.openxmlformats.org/presentationml/2006/main">
+  <p:cSld name="Slide 9">
+    <p:spTree>
+      <p:nvGrpSpPr>
+        <p:cNvPr id="1" name=""/>
+        <p:cNvGrpSpPr/>
+        <p:nvPr/>
+      </p:nvGrpSpPr>
+      <p:grpSpPr>
+        <a:xfrm>
+          <a:off x="0" y="0"/>
+          <a:ext cx="0" cy="0"/>
+          <a:chOff x="0" y="0"/>
+          <a:chExt cx="0" cy="0"/>
+        </a:xfrm>
+      </p:grpSpPr>
+      <p:sp>
+        <p:nvSpPr>
+          <p:cNvPr id="2" name="Text 0"/>
+          <p:cNvSpPr txBox="1"/>
+          <p:nvPr/>
+        </p:nvSpPr>
+        <p:spPr>
+          <a:xfrm>
+            <a:off x="502920" y="201168"/>
+            <a:ext cx="8138160" cy="256032"/>
+          </a:xfrm>
+          <a:prstGeom prst="rect">
+            <a:avLst/>
+          </a:prstGeom>
+          <a:noFill/>
+          <a:ln/>
+        </p:spPr>
+        <p:txBody>
+          <a:bodyPr wrap="square" lIns="0" tIns="0" rIns="0" bIns="0" rtlCol="0" anchor="ctr"/>
+          <a:lstStyle/>
+          <a:p>
+            <a:pPr marL="0" indent="0">
+              <a:buNone/>
+            </a:pPr>
+            <a:r>
+              <a:rPr lang="en-US" sz="1000" b="1" kern="0" spc="300" dirty="0">
+                <a:solidFill>
+                  <a:srgbClr val="D4824A"/>
+                </a:solidFill>
+              </a:rPr>
+              <a:t>DSPY FUNDAMENTALS  ·  7 OF 7</a:t>
+            </a:r>
+            <a:endParaRPr lang="en-US" sz="1000" dirty="0"/>
+          </a:p>
+        </p:txBody>
+      </p:sp>
+      <p:sp>
+        <p:nvSpPr>
+          <p:cNvPr id="3" name="Text 1"/>
+          <p:cNvSpPr>
+            <a:spLocks noGrp="1"/>
+          </p:cNvSpPr>
+          <p:nvPr>
+            <p:ph type="title" idx="101" hasCustomPrompt="1"/>
+          </p:nvPr>
+        </p:nvSpPr>
+        <p:spPr>
+          <a:xfrm>
+            <a:off x="502920" y="457200"/>
+            <a:ext cx="8138160" cy="594360"/>
+          </a:xfrm>
+          <a:prstGeom prst="rect">
+            <a:avLst/>
+          </a:prstGeom>
+          <a:noFill/>
+          <a:ln/>
+        </p:spPr>
+        <p:txBody>
+          <a:bodyPr wrap="square" lIns="0" tIns="0" rIns="0" bIns="0" rtlCol="0" anchor="ctr"/>
+          <a:lstStyle/>
+          <a:p>
+            <a:pPr marL="0" indent="0" algn="l">
+              <a:buNone/>
+            </a:pPr>
+            <a:r>
+              <a:rPr lang="en-US" sz="2800" b="1" dirty="0">
+                <a:solidFill>
+                  <a:srgbClr val="1B2A4A"/>
+                </a:solidFill>
+              </a:rPr>
+              <a:t>Predict, ChainOfThought, and ReAct</a:t>
+            </a:r>
+            <a:endParaRPr lang="en-US" sz="2800" dirty="0"/>
+          </a:p>
+        </p:txBody>
+      </p:sp>
+      <p:sp>
+        <p:nvSpPr>
+          <p:cNvPr id="4" name="Shape 2"/>
+          <p:cNvSpPr/>
+          <p:nvPr/>
+        </p:nvSpPr>
+        <p:spPr>
+          <a:xfrm>
+            <a:off x="502920" y="1280160"/>
+            <a:ext cx="2514600" cy="2331720"/>
+          </a:xfrm>
+          <a:prstGeom prst="roundRect">
+            <a:avLst>
+              <a:gd name="adj" fmla="val 3922"/>
+            </a:avLst>
+          </a:prstGeom>
+          <a:solidFill>
+            <a:srgbClr val="F4F6F9"/>
+          </a:solidFill>
+          <a:ln w="12700">
+            <a:solidFill>
+              <a:srgbClr val="F4F6F9"/>
+            </a:solidFill>
+            <a:prstDash val="solid"/>
+          </a:ln>
+        </p:spPr>
+      </p:sp>
+      <p:sp>
+        <p:nvSpPr>
+          <p:cNvPr id="5" name="Shape 3"/>
+          <p:cNvSpPr/>
+          <p:nvPr/>
+        </p:nvSpPr>
+        <p:spPr>
+          <a:xfrm>
+            <a:off x="502920" y="1280160"/>
+            <a:ext cx="2514600" cy="548640"/>
+          </a:xfrm>
+          <a:prstGeom prst="roundRect">
+            <a:avLst>
+              <a:gd name="adj" fmla="val 16667"/>
+            </a:avLst>
+          </a:prstGeom>
+          <a:solidFill>
+            <a:srgbClr val="1B2A4A"/>
+          </a:solidFill>
+          <a:ln w="12700">
+            <a:solidFill>
+              <a:srgbClr val="1B2A4A"/>
+            </a:solidFill>
+            <a:prstDash val="solid"/>
+          </a:ln>
+        </p:spPr>
+      </p:sp>
+      <p:sp>
+        <p:nvSpPr>
+          <p:cNvPr id="6" name="Text 4"/>
+          <p:cNvSpPr txBox="1"/>
+          <p:nvPr/>
+        </p:nvSpPr>
+        <p:spPr>
+          <a:xfrm>
+            <a:off x="502920" y="1280160"/>
+            <a:ext cx="2514600" cy="548640"/>
+          </a:xfrm>
+          <a:prstGeom prst="rect">
+            <a:avLst/>
+          </a:prstGeom>
+          <a:noFill/>
+          <a:ln/>
+        </p:spPr>
+        <p:txBody>
+          <a:bodyPr wrap="square" lIns="0" tIns="0" rIns="0" bIns="0" rtlCol="0" anchor="ctr"/>
+          <a:lstStyle/>
+          <a:p>
+            <a:pPr marL="0" indent="0" algn="ctr">
+              <a:buNone/>
+            </a:pPr>
+            <a:r>
+              <a:rPr lang="en-US" sz="1400" b="1" dirty="0">
+                <a:solidFill>
+                  <a:srgbClr val="FFFFFF"/>
+                </a:solidFill>
+                <a:latin typeface="Consolas" pitchFamily="34" charset="0"/>
+                <a:ea typeface="Consolas" pitchFamily="34" charset="-122"/>
+                <a:cs typeface="Consolas" pitchFamily="34" charset="-120"/>
+              </a:rPr>
+              <a:t>dspy.Predict</a:t>
+            </a:r>
+            <a:endParaRPr lang="en-US" sz="1400" dirty="0"/>
+          </a:p>
+        </p:txBody>
+      </p:sp>
+      <p:sp>
+        <p:nvSpPr>
+          <p:cNvPr id="7" name="Text 5"/>
+          <p:cNvSpPr txBox="1"/>
+          <p:nvPr/>
+        </p:nvSpPr>
+        <p:spPr>
+          <a:xfrm>
+            <a:off x="704088" y="1965960"/>
+            <a:ext cx="2112264" cy="1554480"/>
+          </a:xfrm>
+          <a:prstGeom prst="rect">
+            <a:avLst/>
+          </a:prstGeom>
+          <a:noFill/>
+          <a:ln/>
+        </p:spPr>
+        <p:txBody>
+          <a:bodyPr wrap="square" lIns="0" tIns="0" rIns="0" bIns="0" rtlCol="0" anchor="t"/>
+          <a:lstStyle/>
+          <a:p>
+            <a:pPr marL="0" indent="0">
+              <a:buNone/>
+            </a:pPr>
+            <a:r>
+              <a:rPr lang="en-US" sz="950" b="1" kern="0" spc="200" dirty="0">
+                <a:solidFill>
+                  <a:srgbClr val="D4824A"/>
+                </a:solidFill>
+              </a:rPr>
+              <a:t>HOW</a:t>
+            </a:r>
+            <a:endParaRPr lang="en-US" sz="950" dirty="0"/>
+          </a:p>
+          <a:p>
+            <a:pPr marL="0" indent="0">
+              <a:buNone/>
+            </a:pPr>
+            <a:r>
+              <a:rPr lang="en-US" sz="1400" dirty="0">
+                <a:solidFill>
+                  <a:srgbClr val="1B2A4A"/>
+                </a:solidFill>
+              </a:rPr>
+              <a:t>One LLM call, answer directly</a:t>
+            </a:r>
+            <a:endParaRPr lang="en-US" sz="950" dirty="0"/>
+          </a:p>
+          <a:p>
+            <a:pPr marL="0" indent="0">
+              <a:buNone/>
+            </a:pPr>
+            <a:r>
+              <a:rPr lang="en-US" sz="600" dirty="0">
+                <a:solidFill>
+                  <a:srgbClr val="000000"/>
+                </a:solidFill>
+              </a:rPr>
+              <a:t> </a:t>
+            </a:r>
+            <a:endParaRPr lang="en-US" sz="950" dirty="0"/>
+          </a:p>
+          <a:p>
+            <a:pPr marL="0" indent="0">
+              <a:buNone/>
+            </a:pPr>
+            <a:r>
+              <a:rPr lang="en-US" sz="950" b="1" kern="0" spc="200" dirty="0">
+                <a:solidFill>
+                  <a:srgbClr val="D4824A"/>
+                </a:solidFill>
+              </a:rPr>
+              <a:t>BEST FOR</a:t>
+            </a:r>
+            <a:endParaRPr lang="en-US" sz="950" dirty="0"/>
+          </a:p>
+          <a:p>
+            <a:pPr marL="0" indent="0">
+              <a:buNone/>
+            </a:pPr>
+            <a:r>
+              <a:rPr lang="en-US" sz="1400" dirty="0">
+                <a:solidFill>
+                  <a:srgbClr val="1B2A4A"/>
+                </a:solidFill>
+              </a:rPr>
+              <a:t>Classification, extraction</a:t>
+            </a:r>
+            <a:endParaRPr lang="en-US" sz="950" dirty="0"/>
+          </a:p>
+        </p:txBody>
+      </p:sp>
+      <p:sp>
+        <p:nvSpPr>
+          <p:cNvPr id="8" name="Shape 6"/>
+          <p:cNvSpPr/>
+          <p:nvPr/>
+        </p:nvSpPr>
+        <p:spPr>
+          <a:xfrm>
+            <a:off x="3314700" y="1280160"/>
+            <a:ext cx="2514600" cy="2331720"/>
+          </a:xfrm>
+          <a:prstGeom prst="roundRect">
+            <a:avLst>
+              <a:gd name="adj" fmla="val 3922"/>
+            </a:avLst>
+          </a:prstGeom>
+          <a:solidFill>
+            <a:srgbClr val="F4F6F9"/>
+          </a:solidFill>
+          <a:ln w="12700">
+            <a:solidFill>
+              <a:srgbClr val="F4F6F9"/>
+            </a:solidFill>
+            <a:prstDash val="solid"/>
+          </a:ln>
+        </p:spPr>
+      </p:sp>
+      <p:sp>
+        <p:nvSpPr>
+          <p:cNvPr id="9" name="Shape 7"/>
+          <p:cNvSpPr/>
+          <p:nvPr/>
+        </p:nvSpPr>
+        <p:spPr>
+          <a:xfrm>
+            <a:off x="3314700" y="1280160"/>
+            <a:ext cx="2514600" cy="548640"/>
+          </a:xfrm>
+          <a:prstGeom prst="roundRect">
+            <a:avLst>
+              <a:gd name="adj" fmla="val 16667"/>
+            </a:avLst>
+          </a:prstGeom>
+          <a:solidFill>
+            <a:srgbClr val="D4824A"/>
+          </a:solidFill>
+          <a:ln w="12700">
+            <a:solidFill>
+              <a:srgbClr val="D4824A"/>
+            </a:solidFill>
+            <a:prstDash val="solid"/>
+          </a:ln>
+        </p:spPr>
+      </p:sp>
+      <p:sp>
+        <p:nvSpPr>
+          <p:cNvPr id="10" name="Text 8"/>
+          <p:cNvSpPr txBox="1"/>
+          <p:nvPr/>
+        </p:nvSpPr>
+        <p:spPr>
+          <a:xfrm>
+            <a:off x="3314700" y="1280160"/>
+            <a:ext cx="2514600" cy="548640"/>
+          </a:xfrm>
+          <a:prstGeom prst="rect">
+            <a:avLst/>
+          </a:prstGeom>
+          <a:noFill/>
+          <a:ln/>
+        </p:spPr>
+        <p:txBody>
+          <a:bodyPr wrap="square" lIns="0" tIns="0" rIns="0" bIns="0" rtlCol="0" anchor="ctr"/>
+          <a:lstStyle/>
+          <a:p>
+            <a:pPr marL="0" indent="0" algn="ctr">
+              <a:buNone/>
+            </a:pPr>
+            <a:r>
+              <a:rPr lang="en-US" sz="1400" b="1" dirty="0">
+                <a:solidFill>
+                  <a:srgbClr val="FFFFFF"/>
+                </a:solidFill>
+                <a:latin typeface="Consolas" pitchFamily="34" charset="0"/>
+                <a:ea typeface="Consolas" pitchFamily="34" charset="-122"/>
+                <a:cs typeface="Consolas" pitchFamily="34" charset="-120"/>
+              </a:rPr>
+              <a:t>dspy.ChainOfThought</a:t>
+            </a:r>
+            <a:endParaRPr lang="en-US" sz="1400" dirty="0"/>
+          </a:p>
+        </p:txBody>
+      </p:sp>
+      <p:sp>
+        <p:nvSpPr>
+          <p:cNvPr id="11" name="Text 9"/>
+          <p:cNvSpPr txBox="1"/>
+          <p:nvPr/>
+        </p:nvSpPr>
+        <p:spPr>
+          <a:xfrm>
+            <a:off x="3515868" y="1965960"/>
+            <a:ext cx="2112264" cy="1554480"/>
+          </a:xfrm>
+          <a:prstGeom prst="rect">
+            <a:avLst/>
+          </a:prstGeom>
+          <a:noFill/>
+          <a:ln/>
+        </p:spPr>
+        <p:txBody>
+          <a:bodyPr wrap="square" lIns="0" tIns="0" rIns="0" bIns="0" rtlCol="0" anchor="t"/>
+          <a:lstStyle/>
+          <a:p>
+            <a:pPr marL="0" indent="0">
+              <a:buNone/>
+            </a:pPr>
+            <a:r>
+              <a:rPr lang="en-US" sz="950" b="1" kern="0" spc="200" dirty="0">
+                <a:solidFill>
+                  <a:srgbClr val="D4824A"/>
+                </a:solidFill>
+              </a:rPr>
+              <a:t>HOW</a:t>
+            </a:r>
+            <a:endParaRPr lang="en-US" sz="950" dirty="0"/>
+          </a:p>
+          <a:p>
+            <a:pPr marL="0" indent="0">
+              <a:buNone/>
+            </a:pPr>
+            <a:r>
+              <a:rPr lang="en-US" sz="1400" dirty="0">
+                <a:solidFill>
+                  <a:srgbClr val="1B2A4A"/>
+                </a:solidFill>
+              </a:rPr>
+              <a:t>Reasons first, then answers</a:t>
+            </a:r>
+            <a:endParaRPr lang="en-US" sz="950" dirty="0"/>
+          </a:p>
+          <a:p>
+            <a:pPr marL="0" indent="0">
+              <a:buNone/>
+            </a:pPr>
+            <a:r>
+              <a:rPr lang="en-US" sz="600" dirty="0">
+                <a:solidFill>
+                  <a:srgbClr val="000000"/>
+                </a:solidFill>
+              </a:rPr>
+              <a:t> </a:t>
+            </a:r>
+            <a:endParaRPr lang="en-US" sz="950" dirty="0"/>
+          </a:p>
+          <a:p>
+            <a:pPr marL="0" indent="0">
+              <a:buNone/>
+            </a:pPr>
+            <a:r>
+              <a:rPr lang="en-US" sz="950" b="1" kern="0" spc="200" dirty="0">
+                <a:solidFill>
+                  <a:srgbClr val="D4824A"/>
+                </a:solidFill>
+              </a:rPr>
+              <a:t>BEST FOR</a:t>
+            </a:r>
+            <a:endParaRPr lang="en-US" sz="950" dirty="0"/>
+          </a:p>
+          <a:p>
+            <a:pPr marL="0" indent="0">
+              <a:buNone/>
+            </a:pPr>
+            <a:r>
+              <a:rPr lang="en-US" sz="1400" dirty="0">
+                <a:solidFill>
+                  <a:srgbClr val="1B2A4A"/>
+                </a:solidFill>
+              </a:rPr>
+              <a:t>Multi-step reasoning, math</a:t>
+            </a:r>
+            <a:endParaRPr lang="en-US" sz="950" dirty="0"/>
+          </a:p>
+        </p:txBody>
+      </p:sp>
+      <p:sp>
+        <p:nvSpPr>
+          <p:cNvPr id="12" name="Shape 10"/>
+          <p:cNvSpPr/>
+          <p:nvPr/>
+        </p:nvSpPr>
+        <p:spPr>
+          <a:xfrm>
+            <a:off x="6126480" y="1280160"/>
+            <a:ext cx="2514600" cy="2331720"/>
+          </a:xfrm>
+          <a:prstGeom prst="roundRect">
+            <a:avLst>
+              <a:gd name="adj" fmla="val 3922"/>
+            </a:avLst>
+          </a:prstGeom>
+          <a:solidFill>
+            <a:srgbClr val="F4F6F9"/>
+          </a:solidFill>
+          <a:ln w="12700">
+            <a:solidFill>
+              <a:srgbClr val="F4F6F9"/>
+            </a:solidFill>
+            <a:prstDash val="solid"/>
+          </a:ln>
+        </p:spPr>
+      </p:sp>
+      <p:sp>
+        <p:nvSpPr>
+          <p:cNvPr id="13" name="Shape 11"/>
+          <p:cNvSpPr/>
+          <p:nvPr/>
+        </p:nvSpPr>
+        <p:spPr>
+          <a:xfrm>
+            <a:off x="6126480" y="1280160"/>
+            <a:ext cx="2514600" cy="548640"/>
+          </a:xfrm>
+          <a:prstGeom prst="roundRect">
+            <a:avLst>
+              <a:gd name="adj" fmla="val 16667"/>
+            </a:avLst>
+          </a:prstGeom>
+          <a:solidFill>
+            <a:srgbClr val="1B2A4A"/>
+          </a:solidFill>
+          <a:ln w="12700">
+            <a:solidFill>
+              <a:srgbClr val="1B2A4A"/>
+            </a:solidFill>
+            <a:prstDash val="solid"/>
+          </a:ln>
+        </p:spPr>
+      </p:sp>
+      <p:sp>
+        <p:nvSpPr>
+          <p:cNvPr id="14" name="Text 12"/>
+          <p:cNvSpPr txBox="1"/>
+          <p:nvPr/>
+        </p:nvSpPr>
+        <p:spPr>
+          <a:xfrm>
+            <a:off x="6126480" y="1280160"/>
+            <a:ext cx="2514600" cy="548640"/>
+          </a:xfrm>
+          <a:prstGeom prst="rect">
+            <a:avLst/>
+          </a:prstGeom>
+          <a:noFill/>
+          <a:ln/>
+        </p:spPr>
+        <p:txBody>
+          <a:bodyPr wrap="square" lIns="0" tIns="0" rIns="0" bIns="0" rtlCol="0" anchor="ctr"/>
+          <a:lstStyle/>
+          <a:p>
+            <a:pPr marL="0" indent="0" algn="ctr">
+              <a:buNone/>
+            </a:pPr>
+            <a:r>
+              <a:rPr lang="en-US" sz="1400" b="1" dirty="0">
+                <a:solidFill>
+                  <a:srgbClr val="FFFFFF"/>
+                </a:solidFill>
+                <a:latin typeface="Consolas" pitchFamily="34" charset="0"/>
+                <a:ea typeface="Consolas" pitchFamily="34" charset="-122"/>
+                <a:cs typeface="Consolas" pitchFamily="34" charset="-120"/>
+              </a:rPr>
+              <a:t>dspy.ReAct</a:t>
+            </a:r>
+            <a:endParaRPr lang="en-US" sz="1400" dirty="0"/>
+          </a:p>
+        </p:txBody>
+      </p:sp>
+      <p:sp>
+        <p:nvSpPr>
+          <p:cNvPr id="15" name="Text 13"/>
+          <p:cNvSpPr txBox="1"/>
+          <p:nvPr/>
+        </p:nvSpPr>
+        <p:spPr>
+          <a:xfrm>
+            <a:off x="6327648" y="1965960"/>
+            <a:ext cx="2112264" cy="1554480"/>
+          </a:xfrm>
+          <a:prstGeom prst="rect">
+            <a:avLst/>
+          </a:prstGeom>
+          <a:noFill/>
+          <a:ln/>
+        </p:spPr>
+        <p:txBody>
+          <a:bodyPr wrap="square" lIns="0" tIns="0" rIns="0" bIns="0" rtlCol="0" anchor="t"/>
+          <a:lstStyle/>
+          <a:p>
+            <a:pPr marL="0" indent="0">
+              <a:buNone/>
+            </a:pPr>
+            <a:r>
+              <a:rPr lang="en-US" sz="950" b="1" kern="0" spc="200" dirty="0">
+                <a:solidFill>
+                  <a:srgbClr val="D4824A"/>
+                </a:solidFill>
+              </a:rPr>
+              <a:t>HOW</a:t>
+            </a:r>
+            <a:endParaRPr lang="en-US" sz="950" dirty="0"/>
+          </a:p>
+          <a:p>
+            <a:pPr marL="0" indent="0">
+              <a:buNone/>
+            </a:pPr>
+            <a:r>
+              <a:rPr lang="en-US" sz="1400" dirty="0">
+                <a:solidFill>
+                  <a:srgbClr val="1B2A4A"/>
+                </a:solidFill>
+              </a:rPr>
+              <a:t>Thought → Action → Observation loop</a:t>
+            </a:r>
+            <a:endParaRPr lang="en-US" sz="950" dirty="0"/>
+          </a:p>
+          <a:p>
+            <a:pPr marL="0" indent="0">
+              <a:buNone/>
+            </a:pPr>
+            <a:r>
+              <a:rPr lang="en-US" sz="600" dirty="0">
+                <a:solidFill>
+                  <a:srgbClr val="000000"/>
+                </a:solidFill>
+              </a:rPr>
+              <a:t> </a:t>
+            </a:r>
+            <a:endParaRPr lang="en-US" sz="950" dirty="0"/>
+          </a:p>
+          <a:p>
+            <a:pPr marL="0" indent="0">
+              <a:buNone/>
+            </a:pPr>
+            <a:r>
+              <a:rPr lang="en-US" sz="950" b="1" kern="0" spc="200" dirty="0">
+                <a:solidFill>
+                  <a:srgbClr val="D4824A"/>
+                </a:solidFill>
+              </a:rPr>
+              <a:t>BEST FOR</a:t>
+            </a:r>
+            <a:endParaRPr lang="en-US" sz="950" dirty="0"/>
+          </a:p>
+          <a:p>
+            <a:pPr marL="0" indent="0">
+              <a:buNone/>
+            </a:pPr>
+            <a:r>
+              <a:rPr lang="en-US" sz="1400" dirty="0">
+                <a:solidFill>
+                  <a:srgbClr val="1B2A4A"/>
+                </a:solidFill>
+              </a:rPr>
+              <a:t>Agents that use tools</a:t>
+            </a:r>
+            <a:endParaRPr lang="en-US" sz="950" dirty="0"/>
+          </a:p>
+        </p:txBody>
+      </p:sp>
+      <p:sp>
+        <p:nvSpPr>
+          <p:cNvPr id="16" name="Shape 14"/>
+          <p:cNvSpPr/>
+          <p:nvPr/>
+        </p:nvSpPr>
+        <p:spPr>
+          <a:xfrm>
+            <a:off x="502920" y="3840480"/>
+            <a:ext cx="8138160" cy="594360"/>
+          </a:xfrm>
+          <a:prstGeom prst="roundRect">
+            <a:avLst>
+              <a:gd name="adj" fmla="val 12308"/>
+            </a:avLst>
+          </a:prstGeom>
+          <a:solidFill>
+            <a:srgbClr val="FBEFE6"/>
+          </a:solidFill>
+          <a:ln w="12700">
+            <a:solidFill>
+              <a:srgbClr val="FBEFE6"/>
+            </a:solidFill>
+            <a:prstDash val="solid"/>
+          </a:ln>
+        </p:spPr>
+      </p:sp>
+      <p:sp>
+        <p:nvSpPr>
+          <p:cNvPr id="17" name="Text 15"/>
+          <p:cNvSpPr txBox="1"/>
+          <p:nvPr/>
+        </p:nvSpPr>
+        <p:spPr>
+          <a:xfrm>
+            <a:off x="667512" y="3840480"/>
+            <a:ext cx="7808976" cy="594360"/>
+          </a:xfrm>
+          <a:prstGeom prst="rect">
+            <a:avLst/>
+          </a:prstGeom>
+          <a:noFill/>
+          <a:ln/>
+        </p:spPr>
+        <p:txBody>
+          <a:bodyPr wrap="square" lIns="0" tIns="0" rIns="0" bIns="0" rtlCol="0" anchor="ctr"/>
+          <a:lstStyle/>
+          <a:p>
+            <a:pPr marL="0" indent="0">
+              <a:buNone/>
+            </a:pPr>
+            <a:r>
+              <a:rPr lang="en-US" sz="1000" b="1" kern="0" spc="200" dirty="0">
+                <a:solidFill>
+                  <a:srgbClr val="D4824A"/>
+                </a:solidFill>
+              </a:rPr>
+              <a:t>KEY POINT  </a:t>
+            </a:r>
+            <a:r>
+              <a:rPr lang="en-US" sz="1300" dirty="0">
+                <a:solidFill>
+                  <a:srgbClr val="1B2A4A"/>
+                </a:solidFill>
+              </a:rPr>
+              <a:t>Same Signature, three strategies. Change one line to change how the model works.</a:t>
+            </a:r>
+            <a:endParaRPr lang="en-US" sz="1000" dirty="0"/>
+          </a:p>
+        </p:txBody>
+      </p:sp>
+      <p:sp>
+        <p:nvSpPr>
+          <p:cNvPr id="25" name="Slide Number Placeholder 0"/>
+          <p:cNvSpPr>
+            <a:spLocks noGrp="1"/>
+          </p:cNvSpPr>
+          <p:nvPr>
+            <p:ph type="sldNum" sz="quarter" idx="4294967295"/>
+          </p:nvPr>
+        </p:nvSpPr>
+        <p:spPr>
+          <a:xfrm>
+            <a:off x="8229600" y="4800600"/>
+            <a:ext cx="411480" cy="228600"/>
+          </a:xfrm>
+          <a:prstGeom prst="rect">
+            <a:avLst/>
+          </a:prstGeom>
+          <a:extLst>
+            <a:ext uri="{C572A759-6A51-4108-AA02-DFA0A04FC94B}">
+              <ma14:wrappingTextBoxFlag xmlns="" xmlns:ma14="http://schemas.microsoft.com/office/mac/drawingml/2011/main" val="0"/>
+            </a:ext>
+          </a:extLst>
+        </p:spPr>
+        <p:txBody>
+          <a:bodyPr/>
+          <a:lstStyle>
+            <a:lvl1pPr>
+              <a:defRPr sz="900">
+                <a:solidFill>
+                  <a:srgbClr val="A0B0C0"/>
+                </a:solidFill>
+              </a:defRPr>
+            </a:lvl1pPr>
+          </a:lstStyle>
+          <a:p>
+            <a:pPr algn="r"/>
+            <a:fld id="{F7021451-1387-4CA6-816F-3879F97B5CBC}" type="slidenum">
+              <a:rPr lang="en-US" b="0"/>
+              <a:t>10</a:t>
+            </a:fld>
+            <a:endParaRPr lang="en-US"/>
+          </a:p>
+        </p:txBody>
+      </p:sp>
+    </p:spTree>
+  </p:cSld>
+  <p:clrMapOvr>
+    <a:masterClrMapping/>
+  </p:clrMapOvr>
+</p:sld>
+</file>
+
+<file path=ppt/slides/slide11.xml><?xml version="1.0" encoding="utf-8"?>
+<p:sld xmlns:a="http://schemas.openxmlformats.org/drawingml/2006/main" xmlns:r="http://schemas.openxmlformats.org/officeDocument/2006/relationships" xmlns:p="http://schemas.openxmlformats.org/presentationml/2006/main">
   <p:cSld name="Slide 10">
     <p:spTree>
       <p:nvGrpSpPr>
@@ -4382,7 +5155,7 @@
           </a:prstGeom>
           <a:extLst>
             <a:ext uri="{C572A759-6A51-4108-AA02-DFA0A04FC94B}">
-              <ma14:wrappingTextBoxFlag xmlns:ma14="http://schemas.microsoft.com/office/mac/drawingml/2011/main" xmlns="" val="0"/>
+              <ma14:wrappingTextBoxFlag xmlns="" xmlns:ma14="http://schemas.microsoft.com/office/mac/drawingml/2011/main" val="0"/>
             </a:ext>
           </a:extLst>
         </p:spPr>
@@ -4401,7 +5174,7 @@
             <a:pPr algn="r"/>
             <a:fld id="{F7021451-1387-4CA6-816F-3879F97B5CBC}" type="slidenum">
               <a:rPr lang="en-US" b="0"/>
-              <a:t>10</a:t>
+              <a:t>11</a:t>
             </a:fld>
             <a:endParaRPr lang="en-US"/>
           </a:p>
@@ -4415,7 +5188,7 @@
 </p:sld>
 </file>
 
-<file path=ppt/slides/slide11.xml><?xml version="1.0" encoding="utf-8"?>
+<file path=ppt/slides/slide12.xml><?xml version="1.0" encoding="utf-8"?>
 <p:sld xmlns:a="http://schemas.openxmlformats.org/drawingml/2006/main" xmlns:r="http://schemas.openxmlformats.org/officeDocument/2006/relationships" xmlns:p="http://schemas.openxmlformats.org/presentationml/2006/main">
   <p:cSld name="Slide 11">
     <p:spTree>
@@ -5387,7 +6160,7 @@
           </a:prstGeom>
           <a:extLst>
             <a:ext uri="{C572A759-6A51-4108-AA02-DFA0A04FC94B}">
-              <ma14:wrappingTextBoxFlag xmlns:ma14="http://schemas.microsoft.com/office/mac/drawingml/2011/main" xmlns="" val="0"/>
+              <ma14:wrappingTextBoxFlag xmlns="" xmlns:ma14="http://schemas.microsoft.com/office/mac/drawingml/2011/main" val="0"/>
             </a:ext>
           </a:extLst>
         </p:spPr>
@@ -5406,7 +6179,7 @@
             <a:pPr algn="r"/>
             <a:fld id="{F7021451-1387-4CA6-816F-3879F97B5CBC}" type="slidenum">
               <a:rPr lang="en-US" b="0"/>
-              <a:t>11</a:t>
+              <a:t>12</a:t>
             </a:fld>
             <a:endParaRPr lang="en-US"/>
           </a:p>
@@ -5420,7 +6193,7 @@
 </p:sld>
 </file>
 
-<file path=ppt/slides/slide12.xml><?xml version="1.0" encoding="utf-8"?>
+<file path=ppt/slides/slide13.xml><?xml version="1.0" encoding="utf-8"?>
 <p:sld xmlns:a="http://schemas.openxmlformats.org/drawingml/2006/main" xmlns:r="http://schemas.openxmlformats.org/officeDocument/2006/relationships" xmlns:p="http://schemas.openxmlformats.org/presentationml/2006/main">
   <p:cSld name="Slide 12">
     <p:spTree>
@@ -6445,7 +7218,7 @@
           </a:prstGeom>
           <a:extLst>
             <a:ext uri="{C572A759-6A51-4108-AA02-DFA0A04FC94B}">
-              <ma14:wrappingTextBoxFlag xmlns:ma14="http://schemas.microsoft.com/office/mac/drawingml/2011/main" xmlns="" val="0"/>
+              <ma14:wrappingTextBoxFlag xmlns="" xmlns:ma14="http://schemas.microsoft.com/office/mac/drawingml/2011/main" val="0"/>
             </a:ext>
           </a:extLst>
         </p:spPr>
@@ -6464,7 +7237,7 @@
             <a:pPr algn="r"/>
             <a:fld id="{F7021451-1387-4CA6-816F-3879F97B5CBC}" type="slidenum">
               <a:rPr lang="en-US" b="0"/>
-              <a:t>12</a:t>
+              <a:t>13</a:t>
             </a:fld>
             <a:endParaRPr lang="en-US"/>
           </a:p>
@@ -6478,7 +7251,7 @@
 </p:sld>
 </file>
 
-<file path=ppt/slides/slide13.xml><?xml version="1.0" encoding="utf-8"?>
+<file path=ppt/slides/slide14.xml><?xml version="1.0" encoding="utf-8"?>
 <p:sld xmlns:a="http://schemas.openxmlformats.org/drawingml/2006/main" xmlns:r="http://schemas.openxmlformats.org/officeDocument/2006/relationships" xmlns:p="http://schemas.openxmlformats.org/presentationml/2006/main">
   <p:cSld name="Slide 13">
     <p:spTree>
@@ -7740,7 +8513,7 @@
           </a:prstGeom>
           <a:extLst>
             <a:ext uri="{C572A759-6A51-4108-AA02-DFA0A04FC94B}">
-              <ma14:wrappingTextBoxFlag xmlns:ma14="http://schemas.microsoft.com/office/mac/drawingml/2011/main" xmlns="" val="0"/>
+              <ma14:wrappingTextBoxFlag xmlns="" xmlns:ma14="http://schemas.microsoft.com/office/mac/drawingml/2011/main" val="0"/>
             </a:ext>
           </a:extLst>
         </p:spPr>
@@ -7759,7 +8532,7 @@
             <a:pPr algn="r"/>
             <a:fld id="{F7021451-1387-4CA6-816F-3879F97B5CBC}" type="slidenum">
               <a:rPr lang="en-US" b="0"/>
-              <a:t>13</a:t>
+              <a:t>14</a:t>
             </a:fld>
             <a:endParaRPr lang="en-US"/>
           </a:p>
@@ -7773,7 +8546,7 @@
 </p:sld>
 </file>
 
-<file path=ppt/slides/slide14.xml><?xml version="1.0" encoding="utf-8"?>
+<file path=ppt/slides/slide15.xml><?xml version="1.0" encoding="utf-8"?>
 <p:sld xmlns:a="http://schemas.openxmlformats.org/drawingml/2006/main" xmlns:r="http://schemas.openxmlformats.org/officeDocument/2006/relationships" xmlns:p="http://schemas.openxmlformats.org/presentationml/2006/main">
   <p:cSld name="Slide 14">
     <p:spTree>
@@ -8765,7 +9538,7 @@
           </a:prstGeom>
           <a:extLst>
             <a:ext uri="{C572A759-6A51-4108-AA02-DFA0A04FC94B}">
-              <ma14:wrappingTextBoxFlag xmlns:ma14="http://schemas.microsoft.com/office/mac/drawingml/2011/main" xmlns="" val="0"/>
+              <ma14:wrappingTextBoxFlag xmlns="" xmlns:ma14="http://schemas.microsoft.com/office/mac/drawingml/2011/main" val="0"/>
             </a:ext>
           </a:extLst>
         </p:spPr>
@@ -8784,7 +9557,7 @@
             <a:pPr algn="r"/>
             <a:fld id="{F7021451-1387-4CA6-816F-3879F97B5CBC}" type="slidenum">
               <a:rPr lang="en-US" b="0"/>
-              <a:t>14</a:t>
+              <a:t>15</a:t>
             </a:fld>
             <a:endParaRPr lang="en-US"/>
           </a:p>
@@ -8798,7 +9571,7 @@
 </p:sld>
 </file>
 
-<file path=ppt/slides/slide15.xml><?xml version="1.0" encoding="utf-8"?>
+<file path=ppt/slides/slide16.xml><?xml version="1.0" encoding="utf-8"?>
 <p:sld xmlns:a="http://schemas.openxmlformats.org/drawingml/2006/main" xmlns:r="http://schemas.openxmlformats.org/officeDocument/2006/relationships" xmlns:p="http://schemas.openxmlformats.org/presentationml/2006/main">
   <p:cSld name="Slide 15">
     <p:spTree>
@@ -9770,7 +10543,7 @@
           </a:prstGeom>
           <a:extLst>
             <a:ext uri="{C572A759-6A51-4108-AA02-DFA0A04FC94B}">
-              <ma14:wrappingTextBoxFlag xmlns:ma14="http://schemas.microsoft.com/office/mac/drawingml/2011/main" xmlns="" val="0"/>
+              <ma14:wrappingTextBoxFlag xmlns="" xmlns:ma14="http://schemas.microsoft.com/office/mac/drawingml/2011/main" val="0"/>
             </a:ext>
           </a:extLst>
         </p:spPr>
@@ -9789,7 +10562,7 @@
             <a:pPr algn="r"/>
             <a:fld id="{F7021451-1387-4CA6-816F-3879F97B5CBC}" type="slidenum">
               <a:rPr lang="en-US" b="0"/>
-              <a:t>15</a:t>
+              <a:t>16</a:t>
             </a:fld>
             <a:endParaRPr lang="en-US"/>
           </a:p>
@@ -9803,7 +10576,7 @@
 </p:sld>
 </file>
 
-<file path=ppt/slides/slide16.xml><?xml version="1.0" encoding="utf-8"?>
+<file path=ppt/slides/slide17.xml><?xml version="1.0" encoding="utf-8"?>
 <p:sld xmlns:a="http://schemas.openxmlformats.org/drawingml/2006/main" xmlns:r="http://schemas.openxmlformats.org/officeDocument/2006/relationships" xmlns:p="http://schemas.openxmlformats.org/presentationml/2006/main">
   <p:cSld name="Slide 16">
     <p:spTree>
@@ -10726,7 +11499,7 @@
           </a:prstGeom>
           <a:extLst>
             <a:ext uri="{C572A759-6A51-4108-AA02-DFA0A04FC94B}">
-              <ma14:wrappingTextBoxFlag xmlns:ma14="http://schemas.microsoft.com/office/mac/drawingml/2011/main" xmlns="" val="0"/>
+              <ma14:wrappingTextBoxFlag xmlns="" xmlns:ma14="http://schemas.microsoft.com/office/mac/drawingml/2011/main" val="0"/>
             </a:ext>
           </a:extLst>
         </p:spPr>
@@ -10745,7 +11518,7 @@
             <a:pPr algn="r"/>
             <a:fld id="{F7021451-1387-4CA6-816F-3879F97B5CBC}" type="slidenum">
               <a:rPr lang="en-US" b="0"/>
-              <a:t>16</a:t>
+              <a:t>17</a:t>
             </a:fld>
             <a:endParaRPr lang="en-US"/>
           </a:p>
@@ -10759,7 +11532,7 @@
 </p:sld>
 </file>
 
-<file path=ppt/slides/slide17.xml><?xml version="1.0" encoding="utf-8"?>
+<file path=ppt/slides/slide18.xml><?xml version="1.0" encoding="utf-8"?>
 <p:sld xmlns:a="http://schemas.openxmlformats.org/drawingml/2006/main" xmlns:r="http://schemas.openxmlformats.org/officeDocument/2006/relationships" xmlns:p="http://schemas.openxmlformats.org/presentationml/2006/main">
   <p:cSld name="Slide 17">
     <p:spTree>
@@ -11918,7 +12691,7 @@
           </a:prstGeom>
           <a:extLst>
             <a:ext uri="{C572A759-6A51-4108-AA02-DFA0A04FC94B}">
-              <ma14:wrappingTextBoxFlag xmlns:ma14="http://schemas.microsoft.com/office/mac/drawingml/2011/main" xmlns="" val="0"/>
+              <ma14:wrappingTextBoxFlag xmlns="" xmlns:ma14="http://schemas.microsoft.com/office/mac/drawingml/2011/main" val="0"/>
             </a:ext>
           </a:extLst>
         </p:spPr>
@@ -11937,7 +12710,7 @@
             <a:pPr algn="r"/>
             <a:fld id="{F7021451-1387-4CA6-816F-3879F97B5CBC}" type="slidenum">
               <a:rPr lang="en-US" b="0"/>
-              <a:t>17</a:t>
+              <a:t>18</a:t>
             </a:fld>
             <a:endParaRPr lang="en-US"/>
           </a:p>
@@ -11951,7 +12724,7 @@
 </p:sld>
 </file>
 
-<file path=ppt/slides/slide18.xml><?xml version="1.0" encoding="utf-8"?>
+<file path=ppt/slides/slide19.xml><?xml version="1.0" encoding="utf-8"?>
 <p:sld xmlns:a="http://schemas.openxmlformats.org/drawingml/2006/main" xmlns:r="http://schemas.openxmlformats.org/officeDocument/2006/relationships" xmlns:p="http://schemas.openxmlformats.org/presentationml/2006/main">
   <p:cSld name="Slide 18">
     <p:spTree>
@@ -12938,1063 +13711,7 @@
           </a:prstGeom>
           <a:extLst>
             <a:ext uri="{C572A759-6A51-4108-AA02-DFA0A04FC94B}">
-              <ma14:wrappingTextBoxFlag xmlns:ma14="http://schemas.microsoft.com/office/mac/drawingml/2011/main" xmlns="" val="0"/>
-            </a:ext>
-          </a:extLst>
-        </p:spPr>
-        <p:txBody>
-          <a:bodyPr/>
-          <a:lstStyle>
-            <a:lvl1pPr>
-              <a:defRPr sz="900">
-                <a:solidFill>
-                  <a:srgbClr val="A0B0C0"/>
-                </a:solidFill>
-              </a:defRPr>
-            </a:lvl1pPr>
-          </a:lstStyle>
-          <a:p>
-            <a:pPr algn="r"/>
-            <a:fld id="{F7021451-1387-4CA6-816F-3879F97B5CBC}" type="slidenum">
-              <a:rPr lang="en-US" b="0"/>
-              <a:t>18</a:t>
-            </a:fld>
-            <a:endParaRPr lang="en-US"/>
-          </a:p>
-        </p:txBody>
-      </p:sp>
-    </p:spTree>
-  </p:cSld>
-  <p:clrMapOvr>
-    <a:masterClrMapping/>
-  </p:clrMapOvr>
-</p:sld>
-</file>
-
-<file path=ppt/slides/slide19.xml><?xml version="1.0" encoding="utf-8"?>
-<p:sld xmlns:a="http://schemas.openxmlformats.org/drawingml/2006/main" xmlns:r="http://schemas.openxmlformats.org/officeDocument/2006/relationships" xmlns:p="http://schemas.openxmlformats.org/presentationml/2006/main">
-  <p:cSld name="Slide 19">
-    <p:spTree>
-      <p:nvGrpSpPr>
-        <p:cNvPr id="1" name=""/>
-        <p:cNvGrpSpPr/>
-        <p:nvPr/>
-      </p:nvGrpSpPr>
-      <p:grpSpPr>
-        <a:xfrm>
-          <a:off x="0" y="0"/>
-          <a:ext cx="0" cy="0"/>
-          <a:chOff x="0" y="0"/>
-          <a:chExt cx="0" cy="0"/>
-        </a:xfrm>
-      </p:grpSpPr>
-      <p:sp>
-        <p:nvSpPr>
-          <p:cNvPr id="2" name="Text 0"/>
-          <p:cNvSpPr txBox="1"/>
-          <p:nvPr/>
-        </p:nvSpPr>
-        <p:spPr>
-          <a:xfrm>
-            <a:off x="502920" y="201168"/>
-            <a:ext cx="8138160" cy="256032"/>
-          </a:xfrm>
-          <a:prstGeom prst="rect">
-            <a:avLst/>
-          </a:prstGeom>
-          <a:noFill/>
-          <a:ln/>
-        </p:spPr>
-        <p:txBody>
-          <a:bodyPr wrap="square" lIns="0" tIns="0" rIns="0" bIns="0" rtlCol="0" anchor="ctr"/>
-          <a:lstStyle/>
-          <a:p>
-            <a:pPr marL="0" indent="0">
-              <a:buNone/>
-            </a:pPr>
-            <a:r>
-              <a:rPr lang="en-US" sz="1000" b="1" kern="0" spc="300" dirty="0">
-                <a:solidFill>
-                  <a:srgbClr val="D4824A"/>
-                </a:solidFill>
-              </a:rPr>
-              <a:t>ADVANCED &amp; PRODUCTION  ·  2 OF 4</a:t>
-            </a:r>
-            <a:endParaRPr lang="en-US" sz="1000" dirty="0"/>
-          </a:p>
-        </p:txBody>
-      </p:sp>
-      <p:sp>
-        <p:nvSpPr>
-          <p:cNvPr id="3" name="Text 1"/>
-          <p:cNvSpPr>
-            <a:spLocks noGrp="1"/>
-          </p:cNvSpPr>
-          <p:nvPr>
-            <p:ph type="title" idx="101" hasCustomPrompt="1"/>
-          </p:nvPr>
-        </p:nvSpPr>
-        <p:spPr>
-          <a:xfrm>
-            <a:off x="502920" y="457200"/>
-            <a:ext cx="8138160" cy="594360"/>
-          </a:xfrm>
-          <a:prstGeom prst="rect">
-            <a:avLst/>
-          </a:prstGeom>
-          <a:noFill/>
-          <a:ln/>
-        </p:spPr>
-        <p:txBody>
-          <a:bodyPr wrap="square" lIns="0" tIns="0" rIns="0" bIns="0" rtlCol="0" anchor="ctr"/>
-          <a:lstStyle/>
-          <a:p>
-            <a:pPr marL="0" indent="0" algn="l">
-              <a:buNone/>
-            </a:pPr>
-            <a:r>
-              <a:rPr lang="en-US" sz="2800" b="1" dirty="0">
-                <a:solidFill>
-                  <a:srgbClr val="1B2A4A"/>
-                </a:solidFill>
-              </a:rPr>
-              <a:t>DSPy with Multiple LLMs</a:t>
-            </a:r>
-            <a:endParaRPr lang="en-US" sz="2800" dirty="0"/>
-          </a:p>
-        </p:txBody>
-      </p:sp>
-      <p:sp>
-        <p:nvSpPr>
-          <p:cNvPr id="4" name="Shape 2"/>
-          <p:cNvSpPr/>
-          <p:nvPr/>
-        </p:nvSpPr>
-        <p:spPr>
-          <a:xfrm>
-            <a:off x="502920" y="1298448"/>
-            <a:ext cx="329184" cy="329184"/>
-          </a:xfrm>
-          <a:prstGeom prst="ellipse">
-            <a:avLst/>
-          </a:prstGeom>
-          <a:solidFill>
-            <a:srgbClr val="1B2A4A"/>
-          </a:solidFill>
-          <a:ln w="12700">
-            <a:solidFill>
-              <a:srgbClr val="1B2A4A"/>
-            </a:solidFill>
-            <a:prstDash val="solid"/>
-          </a:ln>
-        </p:spPr>
-      </p:sp>
-      <p:sp>
-        <p:nvSpPr>
-          <p:cNvPr id="5" name="Text 3"/>
-          <p:cNvSpPr txBox="1"/>
-          <p:nvPr/>
-        </p:nvSpPr>
-        <p:spPr>
-          <a:xfrm>
-            <a:off x="502920" y="1298448"/>
-            <a:ext cx="329184" cy="329184"/>
-          </a:xfrm>
-          <a:prstGeom prst="rect">
-            <a:avLst/>
-          </a:prstGeom>
-          <a:noFill/>
-          <a:ln/>
-        </p:spPr>
-        <p:txBody>
-          <a:bodyPr wrap="square" lIns="0" tIns="0" rIns="0" bIns="0" rtlCol="0" anchor="ctr"/>
-          <a:lstStyle/>
-          <a:p>
-            <a:pPr marL="0" indent="0" algn="ctr">
-              <a:buNone/>
-            </a:pPr>
-            <a:r>
-              <a:rPr lang="en-US" sz="1300" b="1" dirty="0">
-                <a:solidFill>
-                  <a:srgbClr val="FFFFFF"/>
-                </a:solidFill>
-              </a:rPr>
-              <a:t>1</a:t>
-            </a:r>
-            <a:endParaRPr lang="en-US" sz="1300" dirty="0"/>
-          </a:p>
-        </p:txBody>
-      </p:sp>
-      <p:sp>
-        <p:nvSpPr>
-          <p:cNvPr id="6" name="Text 4"/>
-          <p:cNvSpPr txBox="1"/>
-          <p:nvPr/>
-        </p:nvSpPr>
-        <p:spPr>
-          <a:xfrm>
-            <a:off x="978408" y="1243584"/>
-            <a:ext cx="3364992" cy="621792"/>
-          </a:xfrm>
-          <a:prstGeom prst="rect">
-            <a:avLst/>
-          </a:prstGeom>
-          <a:noFill/>
-          <a:ln/>
-        </p:spPr>
-        <p:txBody>
-          <a:bodyPr wrap="square" lIns="0" tIns="0" rIns="0" bIns="0" rtlCol="0" anchor="t"/>
-          <a:lstStyle/>
-          <a:p>
-            <a:pPr marL="0" indent="0">
-              <a:spcAft>
-                <a:spcPts val="200"/>
-              </a:spcAft>
-              <a:buNone/>
-            </a:pPr>
-            <a:r>
-              <a:rPr lang="en-US" sz="1500" b="1" dirty="0">
-                <a:solidFill>
-                  <a:srgbClr val="1B2A4A"/>
-                </a:solidFill>
-              </a:rPr>
-              <a:t>Set a default: dspy.configure()</a:t>
-            </a:r>
-            <a:endParaRPr lang="en-US" sz="1500" dirty="0"/>
-          </a:p>
-          <a:p>
-            <a:pPr marL="0" indent="0">
-              <a:spcAft>
-                <a:spcPts val="200"/>
-              </a:spcAft>
-              <a:buNone/>
-            </a:pPr>
-            <a:r>
-              <a:rPr lang="en-US" sz="1200" dirty="0">
-                <a:solidFill>
-                  <a:srgbClr val="5F6F80"/>
-                </a:solidFill>
-              </a:rPr>
-              <a:t>Usually the cheap model</a:t>
-            </a:r>
-            <a:endParaRPr lang="en-US" sz="1500" dirty="0"/>
-          </a:p>
-        </p:txBody>
-      </p:sp>
-      <p:sp>
-        <p:nvSpPr>
-          <p:cNvPr id="7" name="Shape 5"/>
-          <p:cNvSpPr/>
-          <p:nvPr/>
-        </p:nvSpPr>
-        <p:spPr>
-          <a:xfrm>
-            <a:off x="502920" y="1920240"/>
-            <a:ext cx="329184" cy="329184"/>
-          </a:xfrm>
-          <a:prstGeom prst="ellipse">
-            <a:avLst/>
-          </a:prstGeom>
-          <a:solidFill>
-            <a:srgbClr val="1B2A4A"/>
-          </a:solidFill>
-          <a:ln w="12700">
-            <a:solidFill>
-              <a:srgbClr val="1B2A4A"/>
-            </a:solidFill>
-            <a:prstDash val="solid"/>
-          </a:ln>
-        </p:spPr>
-      </p:sp>
-      <p:sp>
-        <p:nvSpPr>
-          <p:cNvPr id="8" name="Text 6"/>
-          <p:cNvSpPr txBox="1"/>
-          <p:nvPr/>
-        </p:nvSpPr>
-        <p:spPr>
-          <a:xfrm>
-            <a:off x="502920" y="1920240"/>
-            <a:ext cx="329184" cy="329184"/>
-          </a:xfrm>
-          <a:prstGeom prst="rect">
-            <a:avLst/>
-          </a:prstGeom>
-          <a:noFill/>
-          <a:ln/>
-        </p:spPr>
-        <p:txBody>
-          <a:bodyPr wrap="square" lIns="0" tIns="0" rIns="0" bIns="0" rtlCol="0" anchor="ctr"/>
-          <a:lstStyle/>
-          <a:p>
-            <a:pPr marL="0" indent="0" algn="ctr">
-              <a:buNone/>
-            </a:pPr>
-            <a:r>
-              <a:rPr lang="en-US" sz="1300" b="1" dirty="0">
-                <a:solidFill>
-                  <a:srgbClr val="FFFFFF"/>
-                </a:solidFill>
-              </a:rPr>
-              <a:t>2</a:t>
-            </a:r>
-            <a:endParaRPr lang="en-US" sz="1300" dirty="0"/>
-          </a:p>
-        </p:txBody>
-      </p:sp>
-      <p:sp>
-        <p:nvSpPr>
-          <p:cNvPr id="9" name="Text 7"/>
-          <p:cNvSpPr txBox="1"/>
-          <p:nvPr/>
-        </p:nvSpPr>
-        <p:spPr>
-          <a:xfrm>
-            <a:off x="978408" y="1865376"/>
-            <a:ext cx="3364992" cy="621792"/>
-          </a:xfrm>
-          <a:prstGeom prst="rect">
-            <a:avLst/>
-          </a:prstGeom>
-          <a:noFill/>
-          <a:ln/>
-        </p:spPr>
-        <p:txBody>
-          <a:bodyPr wrap="square" lIns="0" tIns="0" rIns="0" bIns="0" rtlCol="0" anchor="t"/>
-          <a:lstStyle/>
-          <a:p>
-            <a:pPr marL="0" indent="0">
-              <a:spcAft>
-                <a:spcPts val="200"/>
-              </a:spcAft>
-              <a:buNone/>
-            </a:pPr>
-            <a:r>
-              <a:rPr lang="en-US" sz="1500" b="1" dirty="0">
-                <a:solidFill>
-                  <a:srgbClr val="1B2A4A"/>
-                </a:solidFill>
-              </a:rPr>
-              <a:t>Override one step: dspy.context()</a:t>
-            </a:r>
-            <a:endParaRPr lang="en-US" sz="1500" dirty="0"/>
-          </a:p>
-          <a:p>
-            <a:pPr marL="0" indent="0">
-              <a:spcAft>
-                <a:spcPts val="200"/>
-              </a:spcAft>
-              <a:buNone/>
-            </a:pPr>
-            <a:r>
-              <a:rPr lang="en-US" sz="1200" dirty="0">
-                <a:solidFill>
-                  <a:srgbClr val="5F6F80"/>
-                </a:solidFill>
-              </a:rPr>
-              <a:t>Only that call changes model</a:t>
-            </a:r>
-            <a:endParaRPr lang="en-US" sz="1500" dirty="0"/>
-          </a:p>
-        </p:txBody>
-      </p:sp>
-      <p:sp>
-        <p:nvSpPr>
-          <p:cNvPr id="10" name="Shape 8"/>
-          <p:cNvSpPr/>
-          <p:nvPr/>
-        </p:nvSpPr>
-        <p:spPr>
-          <a:xfrm>
-            <a:off x="502920" y="2542032"/>
-            <a:ext cx="329184" cy="329184"/>
-          </a:xfrm>
-          <a:prstGeom prst="ellipse">
-            <a:avLst/>
-          </a:prstGeom>
-          <a:solidFill>
-            <a:srgbClr val="1B2A4A"/>
-          </a:solidFill>
-          <a:ln w="12700">
-            <a:solidFill>
-              <a:srgbClr val="1B2A4A"/>
-            </a:solidFill>
-            <a:prstDash val="solid"/>
-          </a:ln>
-        </p:spPr>
-      </p:sp>
-      <p:sp>
-        <p:nvSpPr>
-          <p:cNvPr id="11" name="Text 9"/>
-          <p:cNvSpPr txBox="1"/>
-          <p:nvPr/>
-        </p:nvSpPr>
-        <p:spPr>
-          <a:xfrm>
-            <a:off x="502920" y="2542032"/>
-            <a:ext cx="329184" cy="329184"/>
-          </a:xfrm>
-          <a:prstGeom prst="rect">
-            <a:avLst/>
-          </a:prstGeom>
-          <a:noFill/>
-          <a:ln/>
-        </p:spPr>
-        <p:txBody>
-          <a:bodyPr wrap="square" lIns="0" tIns="0" rIns="0" bIns="0" rtlCol="0" anchor="ctr"/>
-          <a:lstStyle/>
-          <a:p>
-            <a:pPr marL="0" indent="0" algn="ctr">
-              <a:buNone/>
-            </a:pPr>
-            <a:r>
-              <a:rPr lang="en-US" sz="1300" b="1" dirty="0">
-                <a:solidFill>
-                  <a:srgbClr val="FFFFFF"/>
-                </a:solidFill>
-              </a:rPr>
-              <a:t>3</a:t>
-            </a:r>
-            <a:endParaRPr lang="en-US" sz="1300" dirty="0"/>
-          </a:p>
-        </p:txBody>
-      </p:sp>
-      <p:sp>
-        <p:nvSpPr>
-          <p:cNvPr id="12" name="Text 10"/>
-          <p:cNvSpPr txBox="1"/>
-          <p:nvPr/>
-        </p:nvSpPr>
-        <p:spPr>
-          <a:xfrm>
-            <a:off x="978408" y="2487168"/>
-            <a:ext cx="3364992" cy="621792"/>
-          </a:xfrm>
-          <a:prstGeom prst="rect">
-            <a:avLst/>
-          </a:prstGeom>
-          <a:noFill/>
-          <a:ln/>
-        </p:spPr>
-        <p:txBody>
-          <a:bodyPr wrap="square" lIns="0" tIns="0" rIns="0" bIns="0" rtlCol="0" anchor="t"/>
-          <a:lstStyle/>
-          <a:p>
-            <a:pPr marL="0" indent="0">
-              <a:spcAft>
-                <a:spcPts val="200"/>
-              </a:spcAft>
-              <a:buNone/>
-            </a:pPr>
-            <a:r>
-              <a:rPr lang="en-US" sz="1500" b="1" dirty="0">
-                <a:solidFill>
-                  <a:srgbClr val="1B2A4A"/>
-                </a:solidFill>
-              </a:rPr>
-              <a:t>Cheap model for easy steps</a:t>
-            </a:r>
-            <a:endParaRPr lang="en-US" sz="1500" dirty="0"/>
-          </a:p>
-          <a:p>
-            <a:pPr marL="0" indent="0">
-              <a:spcAft>
-                <a:spcPts val="200"/>
-              </a:spcAft>
-              <a:buNone/>
-            </a:pPr>
-            <a:r>
-              <a:rPr lang="en-US" sz="1200" dirty="0">
-                <a:solidFill>
-                  <a:srgbClr val="5F6F80"/>
-                </a:solidFill>
-              </a:rPr>
-              <a:t>e.g. classify with gpt-4o-mini</a:t>
-            </a:r>
-            <a:endParaRPr lang="en-US" sz="1500" dirty="0"/>
-          </a:p>
-        </p:txBody>
-      </p:sp>
-      <p:sp>
-        <p:nvSpPr>
-          <p:cNvPr id="13" name="Shape 11"/>
-          <p:cNvSpPr/>
-          <p:nvPr/>
-        </p:nvSpPr>
-        <p:spPr>
-          <a:xfrm>
-            <a:off x="502920" y="3163824"/>
-            <a:ext cx="329184" cy="329184"/>
-          </a:xfrm>
-          <a:prstGeom prst="ellipse">
-            <a:avLst/>
-          </a:prstGeom>
-          <a:solidFill>
-            <a:srgbClr val="1B2A4A"/>
-          </a:solidFill>
-          <a:ln w="12700">
-            <a:solidFill>
-              <a:srgbClr val="1B2A4A"/>
-            </a:solidFill>
-            <a:prstDash val="solid"/>
-          </a:ln>
-        </p:spPr>
-      </p:sp>
-      <p:sp>
-        <p:nvSpPr>
-          <p:cNvPr id="14" name="Text 12"/>
-          <p:cNvSpPr txBox="1"/>
-          <p:nvPr/>
-        </p:nvSpPr>
-        <p:spPr>
-          <a:xfrm>
-            <a:off x="502920" y="3163824"/>
-            <a:ext cx="329184" cy="329184"/>
-          </a:xfrm>
-          <a:prstGeom prst="rect">
-            <a:avLst/>
-          </a:prstGeom>
-          <a:noFill/>
-          <a:ln/>
-        </p:spPr>
-        <p:txBody>
-          <a:bodyPr wrap="square" lIns="0" tIns="0" rIns="0" bIns="0" rtlCol="0" anchor="ctr"/>
-          <a:lstStyle/>
-          <a:p>
-            <a:pPr marL="0" indent="0" algn="ctr">
-              <a:buNone/>
-            </a:pPr>
-            <a:r>
-              <a:rPr lang="en-US" sz="1300" b="1" dirty="0">
-                <a:solidFill>
-                  <a:srgbClr val="FFFFFF"/>
-                </a:solidFill>
-              </a:rPr>
-              <a:t>4</a:t>
-            </a:r>
-            <a:endParaRPr lang="en-US" sz="1300" dirty="0"/>
-          </a:p>
-        </p:txBody>
-      </p:sp>
-      <p:sp>
-        <p:nvSpPr>
-          <p:cNvPr id="15" name="Text 13"/>
-          <p:cNvSpPr txBox="1"/>
-          <p:nvPr/>
-        </p:nvSpPr>
-        <p:spPr>
-          <a:xfrm>
-            <a:off x="978408" y="3108960"/>
-            <a:ext cx="3364992" cy="621792"/>
-          </a:xfrm>
-          <a:prstGeom prst="rect">
-            <a:avLst/>
-          </a:prstGeom>
-          <a:noFill/>
-          <a:ln/>
-        </p:spPr>
-        <p:txBody>
-          <a:bodyPr wrap="square" lIns="0" tIns="0" rIns="0" bIns="0" rtlCol="0" anchor="t"/>
-          <a:lstStyle/>
-          <a:p>
-            <a:pPr marL="0" indent="0">
-              <a:spcAft>
-                <a:spcPts val="200"/>
-              </a:spcAft>
-              <a:buNone/>
-            </a:pPr>
-            <a:r>
-              <a:rPr lang="en-US" sz="1500" b="1" dirty="0">
-                <a:solidFill>
-                  <a:srgbClr val="1B2A4A"/>
-                </a:solidFill>
-              </a:rPr>
-              <a:t>Strong model for hard steps</a:t>
-            </a:r>
-            <a:endParaRPr lang="en-US" sz="1500" dirty="0"/>
-          </a:p>
-          <a:p>
-            <a:pPr marL="0" indent="0">
-              <a:spcAft>
-                <a:spcPts val="200"/>
-              </a:spcAft>
-              <a:buNone/>
-            </a:pPr>
-            <a:r>
-              <a:rPr lang="en-US" sz="1200" dirty="0">
-                <a:solidFill>
-                  <a:srgbClr val="5F6F80"/>
-                </a:solidFill>
-              </a:rPr>
-              <a:t>e.g. generate with gpt-4o</a:t>
-            </a:r>
-            <a:endParaRPr lang="en-US" sz="1500" dirty="0"/>
-          </a:p>
-        </p:txBody>
-      </p:sp>
-      <p:sp>
-        <p:nvSpPr>
-          <p:cNvPr id="16" name="Shape 14"/>
-          <p:cNvSpPr/>
-          <p:nvPr/>
-        </p:nvSpPr>
-        <p:spPr>
-          <a:xfrm>
-            <a:off x="502920" y="3913632"/>
-            <a:ext cx="3840480" cy="658368"/>
-          </a:xfrm>
-          <a:prstGeom prst="roundRect">
-            <a:avLst>
-              <a:gd name="adj" fmla="val 11111"/>
-            </a:avLst>
-          </a:prstGeom>
-          <a:solidFill>
-            <a:srgbClr val="FBEFE6"/>
-          </a:solidFill>
-          <a:ln w="12700">
-            <a:solidFill>
-              <a:srgbClr val="FBEFE6"/>
-            </a:solidFill>
-            <a:prstDash val="solid"/>
-          </a:ln>
-        </p:spPr>
-      </p:sp>
-      <p:sp>
-        <p:nvSpPr>
-          <p:cNvPr id="17" name="Text 15"/>
-          <p:cNvSpPr txBox="1"/>
-          <p:nvPr/>
-        </p:nvSpPr>
-        <p:spPr>
-          <a:xfrm>
-            <a:off x="667512" y="3913632"/>
-            <a:ext cx="3511296" cy="658368"/>
-          </a:xfrm>
-          <a:prstGeom prst="rect">
-            <a:avLst/>
-          </a:prstGeom>
-          <a:noFill/>
-          <a:ln/>
-        </p:spPr>
-        <p:txBody>
-          <a:bodyPr wrap="square" lIns="0" tIns="0" rIns="0" bIns="0" rtlCol="0" anchor="ctr"/>
-          <a:lstStyle/>
-          <a:p>
-            <a:pPr marL="0" indent="0">
-              <a:buNone/>
-            </a:pPr>
-            <a:r>
-              <a:rPr lang="en-US" sz="1000" b="1" kern="0" spc="200" dirty="0">
-                <a:solidFill>
-                  <a:srgbClr val="D4824A"/>
-                </a:solidFill>
-              </a:rPr>
-              <a:t>KEY POINT  </a:t>
-            </a:r>
-            <a:r>
-              <a:rPr lang="en-US" sz="1300" dirty="0">
-                <a:solidFill>
-                  <a:srgbClr val="1B2A4A"/>
-                </a:solidFill>
-              </a:rPr>
-              <a:t>Optimize with the best model you can afford; deploy the cheapest that's good enough.</a:t>
-            </a:r>
-            <a:endParaRPr lang="en-US" sz="1000" dirty="0"/>
-          </a:p>
-        </p:txBody>
-      </p:sp>
-      <p:sp>
-        <p:nvSpPr>
-          <p:cNvPr id="18" name="Shape 16"/>
-          <p:cNvSpPr/>
-          <p:nvPr/>
-        </p:nvSpPr>
-        <p:spPr>
-          <a:xfrm>
-            <a:off x="4572000" y="1188720"/>
-            <a:ext cx="4069080" cy="3383280"/>
-          </a:xfrm>
-          <a:prstGeom prst="roundRect">
-            <a:avLst>
-              <a:gd name="adj" fmla="val 2162"/>
-            </a:avLst>
-          </a:prstGeom>
-          <a:solidFill>
-            <a:srgbClr val="1B2A4A"/>
-          </a:solidFill>
-          <a:ln w="12700">
-            <a:solidFill>
-              <a:srgbClr val="1B2A4A"/>
-            </a:solidFill>
-            <a:prstDash val="solid"/>
-          </a:ln>
-        </p:spPr>
-      </p:sp>
-      <p:sp>
-        <p:nvSpPr>
-          <p:cNvPr id="19" name="Text 17"/>
-          <p:cNvSpPr txBox="1"/>
-          <p:nvPr/>
-        </p:nvSpPr>
-        <p:spPr>
-          <a:xfrm>
-            <a:off x="4773168" y="1316736"/>
-            <a:ext cx="3666744" cy="292608"/>
-          </a:xfrm>
-          <a:prstGeom prst="rect">
-            <a:avLst/>
-          </a:prstGeom>
-          <a:noFill/>
-          <a:ln/>
-        </p:spPr>
-        <p:txBody>
-          <a:bodyPr wrap="square" lIns="0" tIns="0" rIns="0" bIns="0" rtlCol="0" anchor="ctr"/>
-          <a:lstStyle/>
-          <a:p>
-            <a:pPr marL="0" indent="0">
-              <a:buNone/>
-            </a:pPr>
-            <a:r>
-              <a:rPr lang="en-US" sz="900" b="1" kern="0" spc="200" dirty="0">
-                <a:solidFill>
-                  <a:srgbClr val="D4824A"/>
-                </a:solidFill>
-              </a:rPr>
-              <a:t>EXAMPLE  </a:t>
-            </a:r>
-            <a:r>
-              <a:rPr lang="en-US" sz="1200" b="1" dirty="0">
-                <a:solidFill>
-                  <a:srgbClr val="FFFFFF"/>
-                </a:solidFill>
-              </a:rPr>
-              <a:t>Multi-model pipeline (demo 10)</a:t>
-            </a:r>
-            <a:endParaRPr lang="en-US" sz="900" dirty="0"/>
-          </a:p>
-        </p:txBody>
-      </p:sp>
-      <p:sp>
-        <p:nvSpPr>
-          <p:cNvPr id="20" name="Text 18"/>
-          <p:cNvSpPr txBox="1"/>
-          <p:nvPr/>
-        </p:nvSpPr>
-        <p:spPr>
-          <a:xfrm>
-            <a:off x="4773168" y="1700784"/>
-            <a:ext cx="3703320" cy="2743200"/>
-          </a:xfrm>
-          <a:prstGeom prst="rect">
-            <a:avLst/>
-          </a:prstGeom>
-          <a:noFill/>
-          <a:ln/>
-        </p:spPr>
-        <p:txBody>
-          <a:bodyPr wrap="square" lIns="0" tIns="0" rIns="0" bIns="0" rtlCol="0" anchor="t"/>
-          <a:lstStyle/>
-          <a:p>
-            <a:pPr marL="0" indent="0">
-              <a:lnSpc>
-                <a:spcPct val="100000"/>
-              </a:lnSpc>
-              <a:buNone/>
-            </a:pPr>
-            <a:r>
-              <a:rPr lang="en-US" sz="1000" dirty="0">
-                <a:solidFill>
-                  <a:srgbClr val="E6EDF5"/>
-                </a:solidFill>
-                <a:latin typeface="Consolas" pitchFamily="34" charset="0"/>
-                <a:ea typeface="Consolas" pitchFamily="34" charset="-122"/>
-                <a:cs typeface="Consolas" pitchFamily="34" charset="-120"/>
-              </a:rPr>
-              <a:t>mini  = dspy.LM("openai/gpt-4o-mini")</a:t>
-            </a:r>
-            <a:endParaRPr lang="en-US" sz="1000" dirty="0"/>
-          </a:p>
-          <a:p>
-            <a:pPr marL="0" indent="0">
-              <a:lnSpc>
-                <a:spcPct val="100000"/>
-              </a:lnSpc>
-              <a:buNone/>
-            </a:pPr>
-            <a:r>
-              <a:rPr lang="en-US" sz="1000" dirty="0">
-                <a:solidFill>
-                  <a:srgbClr val="E6EDF5"/>
-                </a:solidFill>
-                <a:latin typeface="Consolas" pitchFamily="34" charset="0"/>
-                <a:ea typeface="Consolas" pitchFamily="34" charset="-122"/>
-                <a:cs typeface="Consolas" pitchFamily="34" charset="-120"/>
-              </a:rPr>
-              <a:t>gpt4o = dspy.LM("openai/gpt-4o")</a:t>
-            </a:r>
-            <a:endParaRPr lang="en-US" sz="1000" dirty="0"/>
-          </a:p>
-          <a:p>
-            <a:pPr marL="0" indent="0">
-              <a:lnSpc>
-                <a:spcPct val="100000"/>
-              </a:lnSpc>
-              <a:buNone/>
-            </a:pPr>
-            <a:r>
-              <a:rPr lang="en-US" sz="1000" dirty="0">
-                <a:solidFill>
-                  <a:srgbClr val="E6EDF5"/>
-                </a:solidFill>
-                <a:latin typeface="Consolas" pitchFamily="34" charset="0"/>
-                <a:ea typeface="Consolas" pitchFamily="34" charset="-122"/>
-                <a:cs typeface="Consolas" pitchFamily="34" charset="-120"/>
-              </a:rPr>
-              <a:t>dspy.configure(lm=mini)   # default</a:t>
-            </a:r>
-            <a:endParaRPr lang="en-US" sz="1000" dirty="0"/>
-          </a:p>
-          <a:p>
-            <a:pPr marL="0" indent="0">
-              <a:lnSpc>
-                <a:spcPct val="100000"/>
-              </a:lnSpc>
-              <a:buNone/>
-            </a:pPr>
-            <a:endParaRPr lang="en-US" sz="1000" dirty="0"/>
-          </a:p>
-          <a:p>
-            <a:pPr marL="0" indent="0">
-              <a:lnSpc>
-                <a:spcPct val="100000"/>
-              </a:lnSpc>
-              <a:buNone/>
-            </a:pPr>
-            <a:r>
-              <a:rPr lang="en-US" sz="1000" dirty="0">
-                <a:solidFill>
-                  <a:srgbClr val="E6EDF5"/>
-                </a:solidFill>
-                <a:latin typeface="Consolas" pitchFamily="34" charset="0"/>
-                <a:ea typeface="Consolas" pitchFamily="34" charset="-122"/>
-                <a:cs typeface="Consolas" pitchFamily="34" charset="-120"/>
-              </a:rPr>
-              <a:t>class Pipeline(dspy.Module):</a:t>
-            </a:r>
-            <a:endParaRPr lang="en-US" sz="1000" dirty="0"/>
-          </a:p>
-          <a:p>
-            <a:pPr marL="0" indent="0">
-              <a:lnSpc>
-                <a:spcPct val="100000"/>
-              </a:lnSpc>
-              <a:buNone/>
-            </a:pPr>
-            <a:r>
-              <a:rPr lang="en-US" sz="1000" dirty="0">
-                <a:solidFill>
-                  <a:srgbClr val="E6EDF5"/>
-                </a:solidFill>
-                <a:latin typeface="Consolas" pitchFamily="34" charset="0"/>
-                <a:ea typeface="Consolas" pitchFamily="34" charset="-122"/>
-                <a:cs typeface="Consolas" pitchFamily="34" charset="-120"/>
-              </a:rPr>
-              <a:t>    def __init__(self):</a:t>
-            </a:r>
-            <a:endParaRPr lang="en-US" sz="1000" dirty="0"/>
-          </a:p>
-          <a:p>
-            <a:pPr marL="0" indent="0">
-              <a:lnSpc>
-                <a:spcPct val="100000"/>
-              </a:lnSpc>
-              <a:buNone/>
-            </a:pPr>
-            <a:r>
-              <a:rPr lang="en-US" sz="1000" dirty="0">
-                <a:solidFill>
-                  <a:srgbClr val="E6EDF5"/>
-                </a:solidFill>
-                <a:latin typeface="Consolas" pitchFamily="34" charset="0"/>
-                <a:ea typeface="Consolas" pitchFamily="34" charset="-122"/>
-                <a:cs typeface="Consolas" pitchFamily="34" charset="-120"/>
-              </a:rPr>
-              <a:t>        self.classify = dspy.Predict(Intent)</a:t>
-            </a:r>
-            <a:endParaRPr lang="en-US" sz="1000" dirty="0"/>
-          </a:p>
-          <a:p>
-            <a:pPr marL="0" indent="0">
-              <a:lnSpc>
-                <a:spcPct val="100000"/>
-              </a:lnSpc>
-              <a:buNone/>
-            </a:pPr>
-            <a:r>
-              <a:rPr lang="en-US" sz="1000" dirty="0">
-                <a:solidFill>
-                  <a:srgbClr val="E6EDF5"/>
-                </a:solidFill>
-                <a:latin typeface="Consolas" pitchFamily="34" charset="0"/>
-                <a:ea typeface="Consolas" pitchFamily="34" charset="-122"/>
-                <a:cs typeface="Consolas" pitchFamily="34" charset="-120"/>
-              </a:rPr>
-              <a:t>        self.generate = dspy.ChainOfThought(</a:t>
-            </a:r>
-            <a:endParaRPr lang="en-US" sz="1000" dirty="0"/>
-          </a:p>
-          <a:p>
-            <a:pPr marL="0" indent="0">
-              <a:lnSpc>
-                <a:spcPct val="100000"/>
-              </a:lnSpc>
-              <a:buNone/>
-            </a:pPr>
-            <a:r>
-              <a:rPr lang="en-US" sz="1000" dirty="0">
-                <a:solidFill>
-                  <a:srgbClr val="E6EDF5"/>
-                </a:solidFill>
-                <a:latin typeface="Consolas" pitchFamily="34" charset="0"/>
-                <a:ea typeface="Consolas" pitchFamily="34" charset="-122"/>
-                <a:cs typeface="Consolas" pitchFamily="34" charset="-120"/>
-              </a:rPr>
-              <a:t>            Response)</a:t>
-            </a:r>
-            <a:endParaRPr lang="en-US" sz="1000" dirty="0"/>
-          </a:p>
-          <a:p>
-            <a:pPr marL="0" indent="0">
-              <a:lnSpc>
-                <a:spcPct val="100000"/>
-              </a:lnSpc>
-              <a:buNone/>
-            </a:pPr>
-            <a:endParaRPr lang="en-US" sz="1000" dirty="0"/>
-          </a:p>
-          <a:p>
-            <a:pPr marL="0" indent="0">
-              <a:lnSpc>
-                <a:spcPct val="100000"/>
-              </a:lnSpc>
-              <a:buNone/>
-            </a:pPr>
-            <a:r>
-              <a:rPr lang="en-US" sz="1000" dirty="0">
-                <a:solidFill>
-                  <a:srgbClr val="E6EDF5"/>
-                </a:solidFill>
-                <a:latin typeface="Consolas" pitchFamily="34" charset="0"/>
-                <a:ea typeface="Consolas" pitchFamily="34" charset="-122"/>
-                <a:cs typeface="Consolas" pitchFamily="34" charset="-120"/>
-              </a:rPr>
-              <a:t>    def forward(self, query):</a:t>
-            </a:r>
-            <a:endParaRPr lang="en-US" sz="1000" dirty="0"/>
-          </a:p>
-          <a:p>
-            <a:pPr marL="0" indent="0">
-              <a:lnSpc>
-                <a:spcPct val="100000"/>
-              </a:lnSpc>
-              <a:buNone/>
-            </a:pPr>
-            <a:r>
-              <a:rPr lang="en-US" sz="1000" dirty="0">
-                <a:solidFill>
-                  <a:srgbClr val="E6EDF5"/>
-                </a:solidFill>
-                <a:latin typeface="Consolas" pitchFamily="34" charset="0"/>
-                <a:ea typeface="Consolas" pitchFamily="34" charset="-122"/>
-                <a:cs typeface="Consolas" pitchFamily="34" charset="-120"/>
-              </a:rPr>
-              <a:t>        intent = self.classify(query=query)</a:t>
-            </a:r>
-            <a:endParaRPr lang="en-US" sz="1000" dirty="0"/>
-          </a:p>
-          <a:p>
-            <a:pPr marL="0" indent="0">
-              <a:lnSpc>
-                <a:spcPct val="100000"/>
-              </a:lnSpc>
-              <a:buNone/>
-            </a:pPr>
-            <a:r>
-              <a:rPr lang="en-US" sz="1000" dirty="0">
-                <a:solidFill>
-                  <a:srgbClr val="E6EDF5"/>
-                </a:solidFill>
-                <a:latin typeface="Consolas" pitchFamily="34" charset="0"/>
-                <a:ea typeface="Consolas" pitchFamily="34" charset="-122"/>
-                <a:cs typeface="Consolas" pitchFamily="34" charset="-120"/>
-              </a:rPr>
-              <a:t>        with dspy.context(lm=gpt4o):</a:t>
-            </a:r>
-            <a:endParaRPr lang="en-US" sz="1000" dirty="0"/>
-          </a:p>
-          <a:p>
-            <a:pPr marL="0" indent="0">
-              <a:lnSpc>
-                <a:spcPct val="100000"/>
-              </a:lnSpc>
-              <a:buNone/>
-            </a:pPr>
-            <a:r>
-              <a:rPr lang="en-US" sz="1000" dirty="0">
-                <a:solidFill>
-                  <a:srgbClr val="E6EDF5"/>
-                </a:solidFill>
-                <a:latin typeface="Consolas" pitchFamily="34" charset="0"/>
-                <a:ea typeface="Consolas" pitchFamily="34" charset="-122"/>
-                <a:cs typeface="Consolas" pitchFamily="34" charset="-120"/>
-              </a:rPr>
-              <a:t>            return self.generate(query=query,</a:t>
-            </a:r>
-            <a:endParaRPr lang="en-US" sz="1000" dirty="0"/>
-          </a:p>
-          <a:p>
-            <a:pPr marL="0" indent="0">
-              <a:lnSpc>
-                <a:spcPct val="100000"/>
-              </a:lnSpc>
-              <a:buNone/>
-            </a:pPr>
-            <a:r>
-              <a:rPr lang="en-US" sz="1000" dirty="0">
-                <a:solidFill>
-                  <a:srgbClr val="E6EDF5"/>
-                </a:solidFill>
-                <a:latin typeface="Consolas" pitchFamily="34" charset="0"/>
-                <a:ea typeface="Consolas" pitchFamily="34" charset="-122"/>
-                <a:cs typeface="Consolas" pitchFamily="34" charset="-120"/>
-              </a:rPr>
-              <a:t>                intent=intent.category)</a:t>
-            </a:r>
-            <a:endParaRPr lang="en-US" sz="1000" dirty="0"/>
-          </a:p>
-        </p:txBody>
-      </p:sp>
-      <p:sp>
-        <p:nvSpPr>
-          <p:cNvPr id="25" name="Slide Number Placeholder 0"/>
-          <p:cNvSpPr>
-            <a:spLocks noGrp="1"/>
-          </p:cNvSpPr>
-          <p:nvPr>
-            <p:ph type="sldNum" sz="quarter" idx="4294967295"/>
-          </p:nvPr>
-        </p:nvSpPr>
-        <p:spPr>
-          <a:xfrm>
-            <a:off x="8229600" y="4800600"/>
-            <a:ext cx="411480" cy="228600"/>
-          </a:xfrm>
-          <a:prstGeom prst="rect">
-            <a:avLst/>
-          </a:prstGeom>
-          <a:extLst>
-            <a:ext uri="{C572A759-6A51-4108-AA02-DFA0A04FC94B}">
-              <ma14:wrappingTextBoxFlag xmlns:ma14="http://schemas.microsoft.com/office/mac/drawingml/2011/main" xmlns="" val="0"/>
+              <ma14:wrappingTextBoxFlag xmlns="" xmlns:ma14="http://schemas.microsoft.com/office/mac/drawingml/2011/main" val="0"/>
             </a:ext>
           </a:extLst>
         </p:spPr>
@@ -14888,7 +14605,7 @@
           </a:prstGeom>
           <a:extLst>
             <a:ext uri="{C572A759-6A51-4108-AA02-DFA0A04FC94B}">
-              <ma14:wrappingTextBoxFlag xmlns:ma14="http://schemas.microsoft.com/office/mac/drawingml/2011/main" xmlns="" val="0"/>
+              <ma14:wrappingTextBoxFlag xmlns="" xmlns:ma14="http://schemas.microsoft.com/office/mac/drawingml/2011/main" val="0"/>
             </a:ext>
           </a:extLst>
         </p:spPr>
@@ -14922,6 +14639,1062 @@
 </file>
 
 <file path=ppt/slides/slide20.xml><?xml version="1.0" encoding="utf-8"?>
+<p:sld xmlns:a="http://schemas.openxmlformats.org/drawingml/2006/main" xmlns:r="http://schemas.openxmlformats.org/officeDocument/2006/relationships" xmlns:p="http://schemas.openxmlformats.org/presentationml/2006/main">
+  <p:cSld name="Slide 19">
+    <p:spTree>
+      <p:nvGrpSpPr>
+        <p:cNvPr id="1" name=""/>
+        <p:cNvGrpSpPr/>
+        <p:nvPr/>
+      </p:nvGrpSpPr>
+      <p:grpSpPr>
+        <a:xfrm>
+          <a:off x="0" y="0"/>
+          <a:ext cx="0" cy="0"/>
+          <a:chOff x="0" y="0"/>
+          <a:chExt cx="0" cy="0"/>
+        </a:xfrm>
+      </p:grpSpPr>
+      <p:sp>
+        <p:nvSpPr>
+          <p:cNvPr id="2" name="Text 0"/>
+          <p:cNvSpPr txBox="1"/>
+          <p:nvPr/>
+        </p:nvSpPr>
+        <p:spPr>
+          <a:xfrm>
+            <a:off x="502920" y="201168"/>
+            <a:ext cx="8138160" cy="256032"/>
+          </a:xfrm>
+          <a:prstGeom prst="rect">
+            <a:avLst/>
+          </a:prstGeom>
+          <a:noFill/>
+          <a:ln/>
+        </p:spPr>
+        <p:txBody>
+          <a:bodyPr wrap="square" lIns="0" tIns="0" rIns="0" bIns="0" rtlCol="0" anchor="ctr"/>
+          <a:lstStyle/>
+          <a:p>
+            <a:pPr marL="0" indent="0">
+              <a:buNone/>
+            </a:pPr>
+            <a:r>
+              <a:rPr lang="en-US" sz="1000" b="1" kern="0" spc="300" dirty="0">
+                <a:solidFill>
+                  <a:srgbClr val="D4824A"/>
+                </a:solidFill>
+              </a:rPr>
+              <a:t>ADVANCED &amp; PRODUCTION  ·  2 OF 4</a:t>
+            </a:r>
+            <a:endParaRPr lang="en-US" sz="1000" dirty="0"/>
+          </a:p>
+        </p:txBody>
+      </p:sp>
+      <p:sp>
+        <p:nvSpPr>
+          <p:cNvPr id="3" name="Text 1"/>
+          <p:cNvSpPr>
+            <a:spLocks noGrp="1"/>
+          </p:cNvSpPr>
+          <p:nvPr>
+            <p:ph type="title" idx="101" hasCustomPrompt="1"/>
+          </p:nvPr>
+        </p:nvSpPr>
+        <p:spPr>
+          <a:xfrm>
+            <a:off x="502920" y="457200"/>
+            <a:ext cx="8138160" cy="594360"/>
+          </a:xfrm>
+          <a:prstGeom prst="rect">
+            <a:avLst/>
+          </a:prstGeom>
+          <a:noFill/>
+          <a:ln/>
+        </p:spPr>
+        <p:txBody>
+          <a:bodyPr wrap="square" lIns="0" tIns="0" rIns="0" bIns="0" rtlCol="0" anchor="ctr"/>
+          <a:lstStyle/>
+          <a:p>
+            <a:pPr marL="0" indent="0" algn="l">
+              <a:buNone/>
+            </a:pPr>
+            <a:r>
+              <a:rPr lang="en-US" sz="2800" b="1" dirty="0">
+                <a:solidFill>
+                  <a:srgbClr val="1B2A4A"/>
+                </a:solidFill>
+              </a:rPr>
+              <a:t>DSPy with Multiple LLMs</a:t>
+            </a:r>
+            <a:endParaRPr lang="en-US" sz="2800" dirty="0"/>
+          </a:p>
+        </p:txBody>
+      </p:sp>
+      <p:sp>
+        <p:nvSpPr>
+          <p:cNvPr id="4" name="Shape 2"/>
+          <p:cNvSpPr/>
+          <p:nvPr/>
+        </p:nvSpPr>
+        <p:spPr>
+          <a:xfrm>
+            <a:off x="502920" y="1298448"/>
+            <a:ext cx="329184" cy="329184"/>
+          </a:xfrm>
+          <a:prstGeom prst="ellipse">
+            <a:avLst/>
+          </a:prstGeom>
+          <a:solidFill>
+            <a:srgbClr val="1B2A4A"/>
+          </a:solidFill>
+          <a:ln w="12700">
+            <a:solidFill>
+              <a:srgbClr val="1B2A4A"/>
+            </a:solidFill>
+            <a:prstDash val="solid"/>
+          </a:ln>
+        </p:spPr>
+      </p:sp>
+      <p:sp>
+        <p:nvSpPr>
+          <p:cNvPr id="5" name="Text 3"/>
+          <p:cNvSpPr txBox="1"/>
+          <p:nvPr/>
+        </p:nvSpPr>
+        <p:spPr>
+          <a:xfrm>
+            <a:off x="502920" y="1298448"/>
+            <a:ext cx="329184" cy="329184"/>
+          </a:xfrm>
+          <a:prstGeom prst="rect">
+            <a:avLst/>
+          </a:prstGeom>
+          <a:noFill/>
+          <a:ln/>
+        </p:spPr>
+        <p:txBody>
+          <a:bodyPr wrap="square" lIns="0" tIns="0" rIns="0" bIns="0" rtlCol="0" anchor="ctr"/>
+          <a:lstStyle/>
+          <a:p>
+            <a:pPr marL="0" indent="0" algn="ctr">
+              <a:buNone/>
+            </a:pPr>
+            <a:r>
+              <a:rPr lang="en-US" sz="1300" b="1" dirty="0">
+                <a:solidFill>
+                  <a:srgbClr val="FFFFFF"/>
+                </a:solidFill>
+              </a:rPr>
+              <a:t>1</a:t>
+            </a:r>
+            <a:endParaRPr lang="en-US" sz="1300" dirty="0"/>
+          </a:p>
+        </p:txBody>
+      </p:sp>
+      <p:sp>
+        <p:nvSpPr>
+          <p:cNvPr id="6" name="Text 4"/>
+          <p:cNvSpPr txBox="1"/>
+          <p:nvPr/>
+        </p:nvSpPr>
+        <p:spPr>
+          <a:xfrm>
+            <a:off x="978408" y="1243584"/>
+            <a:ext cx="3364992" cy="621792"/>
+          </a:xfrm>
+          <a:prstGeom prst="rect">
+            <a:avLst/>
+          </a:prstGeom>
+          <a:noFill/>
+          <a:ln/>
+        </p:spPr>
+        <p:txBody>
+          <a:bodyPr wrap="square" lIns="0" tIns="0" rIns="0" bIns="0" rtlCol="0" anchor="t"/>
+          <a:lstStyle/>
+          <a:p>
+            <a:pPr marL="0" indent="0">
+              <a:spcAft>
+                <a:spcPts val="200"/>
+              </a:spcAft>
+              <a:buNone/>
+            </a:pPr>
+            <a:r>
+              <a:rPr lang="en-US" sz="1500" b="1" dirty="0">
+                <a:solidFill>
+                  <a:srgbClr val="1B2A4A"/>
+                </a:solidFill>
+              </a:rPr>
+              <a:t>Set a default: dspy.configure()</a:t>
+            </a:r>
+            <a:endParaRPr lang="en-US" sz="1500" dirty="0"/>
+          </a:p>
+          <a:p>
+            <a:pPr marL="0" indent="0">
+              <a:spcAft>
+                <a:spcPts val="200"/>
+              </a:spcAft>
+              <a:buNone/>
+            </a:pPr>
+            <a:r>
+              <a:rPr lang="en-US" sz="1200" dirty="0">
+                <a:solidFill>
+                  <a:srgbClr val="5F6F80"/>
+                </a:solidFill>
+              </a:rPr>
+              <a:t>Usually the cheap model</a:t>
+            </a:r>
+            <a:endParaRPr lang="en-US" sz="1500" dirty="0"/>
+          </a:p>
+        </p:txBody>
+      </p:sp>
+      <p:sp>
+        <p:nvSpPr>
+          <p:cNvPr id="7" name="Shape 5"/>
+          <p:cNvSpPr/>
+          <p:nvPr/>
+        </p:nvSpPr>
+        <p:spPr>
+          <a:xfrm>
+            <a:off x="502920" y="1920240"/>
+            <a:ext cx="329184" cy="329184"/>
+          </a:xfrm>
+          <a:prstGeom prst="ellipse">
+            <a:avLst/>
+          </a:prstGeom>
+          <a:solidFill>
+            <a:srgbClr val="1B2A4A"/>
+          </a:solidFill>
+          <a:ln w="12700">
+            <a:solidFill>
+              <a:srgbClr val="1B2A4A"/>
+            </a:solidFill>
+            <a:prstDash val="solid"/>
+          </a:ln>
+        </p:spPr>
+      </p:sp>
+      <p:sp>
+        <p:nvSpPr>
+          <p:cNvPr id="8" name="Text 6"/>
+          <p:cNvSpPr txBox="1"/>
+          <p:nvPr/>
+        </p:nvSpPr>
+        <p:spPr>
+          <a:xfrm>
+            <a:off x="502920" y="1920240"/>
+            <a:ext cx="329184" cy="329184"/>
+          </a:xfrm>
+          <a:prstGeom prst="rect">
+            <a:avLst/>
+          </a:prstGeom>
+          <a:noFill/>
+          <a:ln/>
+        </p:spPr>
+        <p:txBody>
+          <a:bodyPr wrap="square" lIns="0" tIns="0" rIns="0" bIns="0" rtlCol="0" anchor="ctr"/>
+          <a:lstStyle/>
+          <a:p>
+            <a:pPr marL="0" indent="0" algn="ctr">
+              <a:buNone/>
+            </a:pPr>
+            <a:r>
+              <a:rPr lang="en-US" sz="1300" b="1" dirty="0">
+                <a:solidFill>
+                  <a:srgbClr val="FFFFFF"/>
+                </a:solidFill>
+              </a:rPr>
+              <a:t>2</a:t>
+            </a:r>
+            <a:endParaRPr lang="en-US" sz="1300" dirty="0"/>
+          </a:p>
+        </p:txBody>
+      </p:sp>
+      <p:sp>
+        <p:nvSpPr>
+          <p:cNvPr id="9" name="Text 7"/>
+          <p:cNvSpPr txBox="1"/>
+          <p:nvPr/>
+        </p:nvSpPr>
+        <p:spPr>
+          <a:xfrm>
+            <a:off x="978408" y="1865376"/>
+            <a:ext cx="3364992" cy="621792"/>
+          </a:xfrm>
+          <a:prstGeom prst="rect">
+            <a:avLst/>
+          </a:prstGeom>
+          <a:noFill/>
+          <a:ln/>
+        </p:spPr>
+        <p:txBody>
+          <a:bodyPr wrap="square" lIns="0" tIns="0" rIns="0" bIns="0" rtlCol="0" anchor="t"/>
+          <a:lstStyle/>
+          <a:p>
+            <a:pPr marL="0" indent="0">
+              <a:spcAft>
+                <a:spcPts val="200"/>
+              </a:spcAft>
+              <a:buNone/>
+            </a:pPr>
+            <a:r>
+              <a:rPr lang="en-US" sz="1500" b="1" dirty="0">
+                <a:solidFill>
+                  <a:srgbClr val="1B2A4A"/>
+                </a:solidFill>
+              </a:rPr>
+              <a:t>Override one step: dspy.context()</a:t>
+            </a:r>
+            <a:endParaRPr lang="en-US" sz="1500" dirty="0"/>
+          </a:p>
+          <a:p>
+            <a:pPr marL="0" indent="0">
+              <a:spcAft>
+                <a:spcPts val="200"/>
+              </a:spcAft>
+              <a:buNone/>
+            </a:pPr>
+            <a:r>
+              <a:rPr lang="en-US" sz="1200" dirty="0">
+                <a:solidFill>
+                  <a:srgbClr val="5F6F80"/>
+                </a:solidFill>
+              </a:rPr>
+              <a:t>Only that call changes model</a:t>
+            </a:r>
+            <a:endParaRPr lang="en-US" sz="1500" dirty="0"/>
+          </a:p>
+        </p:txBody>
+      </p:sp>
+      <p:sp>
+        <p:nvSpPr>
+          <p:cNvPr id="10" name="Shape 8"/>
+          <p:cNvSpPr/>
+          <p:nvPr/>
+        </p:nvSpPr>
+        <p:spPr>
+          <a:xfrm>
+            <a:off x="502920" y="2542032"/>
+            <a:ext cx="329184" cy="329184"/>
+          </a:xfrm>
+          <a:prstGeom prst="ellipse">
+            <a:avLst/>
+          </a:prstGeom>
+          <a:solidFill>
+            <a:srgbClr val="1B2A4A"/>
+          </a:solidFill>
+          <a:ln w="12700">
+            <a:solidFill>
+              <a:srgbClr val="1B2A4A"/>
+            </a:solidFill>
+            <a:prstDash val="solid"/>
+          </a:ln>
+        </p:spPr>
+      </p:sp>
+      <p:sp>
+        <p:nvSpPr>
+          <p:cNvPr id="11" name="Text 9"/>
+          <p:cNvSpPr txBox="1"/>
+          <p:nvPr/>
+        </p:nvSpPr>
+        <p:spPr>
+          <a:xfrm>
+            <a:off x="502920" y="2542032"/>
+            <a:ext cx="329184" cy="329184"/>
+          </a:xfrm>
+          <a:prstGeom prst="rect">
+            <a:avLst/>
+          </a:prstGeom>
+          <a:noFill/>
+          <a:ln/>
+        </p:spPr>
+        <p:txBody>
+          <a:bodyPr wrap="square" lIns="0" tIns="0" rIns="0" bIns="0" rtlCol="0" anchor="ctr"/>
+          <a:lstStyle/>
+          <a:p>
+            <a:pPr marL="0" indent="0" algn="ctr">
+              <a:buNone/>
+            </a:pPr>
+            <a:r>
+              <a:rPr lang="en-US" sz="1300" b="1" dirty="0">
+                <a:solidFill>
+                  <a:srgbClr val="FFFFFF"/>
+                </a:solidFill>
+              </a:rPr>
+              <a:t>3</a:t>
+            </a:r>
+            <a:endParaRPr lang="en-US" sz="1300" dirty="0"/>
+          </a:p>
+        </p:txBody>
+      </p:sp>
+      <p:sp>
+        <p:nvSpPr>
+          <p:cNvPr id="12" name="Text 10"/>
+          <p:cNvSpPr txBox="1"/>
+          <p:nvPr/>
+        </p:nvSpPr>
+        <p:spPr>
+          <a:xfrm>
+            <a:off x="978408" y="2487168"/>
+            <a:ext cx="3364992" cy="621792"/>
+          </a:xfrm>
+          <a:prstGeom prst="rect">
+            <a:avLst/>
+          </a:prstGeom>
+          <a:noFill/>
+          <a:ln/>
+        </p:spPr>
+        <p:txBody>
+          <a:bodyPr wrap="square" lIns="0" tIns="0" rIns="0" bIns="0" rtlCol="0" anchor="t"/>
+          <a:lstStyle/>
+          <a:p>
+            <a:pPr marL="0" indent="0">
+              <a:spcAft>
+                <a:spcPts val="200"/>
+              </a:spcAft>
+              <a:buNone/>
+            </a:pPr>
+            <a:r>
+              <a:rPr lang="en-US" sz="1500" b="1" dirty="0">
+                <a:solidFill>
+                  <a:srgbClr val="1B2A4A"/>
+                </a:solidFill>
+              </a:rPr>
+              <a:t>Cheap model for easy steps</a:t>
+            </a:r>
+            <a:endParaRPr lang="en-US" sz="1500" dirty="0"/>
+          </a:p>
+          <a:p>
+            <a:pPr marL="0" indent="0">
+              <a:spcAft>
+                <a:spcPts val="200"/>
+              </a:spcAft>
+              <a:buNone/>
+            </a:pPr>
+            <a:r>
+              <a:rPr lang="en-US" sz="1200" dirty="0">
+                <a:solidFill>
+                  <a:srgbClr val="5F6F80"/>
+                </a:solidFill>
+              </a:rPr>
+              <a:t>e.g. classify with gpt-4o-mini</a:t>
+            </a:r>
+            <a:endParaRPr lang="en-US" sz="1500" dirty="0"/>
+          </a:p>
+        </p:txBody>
+      </p:sp>
+      <p:sp>
+        <p:nvSpPr>
+          <p:cNvPr id="13" name="Shape 11"/>
+          <p:cNvSpPr/>
+          <p:nvPr/>
+        </p:nvSpPr>
+        <p:spPr>
+          <a:xfrm>
+            <a:off x="502920" y="3163824"/>
+            <a:ext cx="329184" cy="329184"/>
+          </a:xfrm>
+          <a:prstGeom prst="ellipse">
+            <a:avLst/>
+          </a:prstGeom>
+          <a:solidFill>
+            <a:srgbClr val="1B2A4A"/>
+          </a:solidFill>
+          <a:ln w="12700">
+            <a:solidFill>
+              <a:srgbClr val="1B2A4A"/>
+            </a:solidFill>
+            <a:prstDash val="solid"/>
+          </a:ln>
+        </p:spPr>
+      </p:sp>
+      <p:sp>
+        <p:nvSpPr>
+          <p:cNvPr id="14" name="Text 12"/>
+          <p:cNvSpPr txBox="1"/>
+          <p:nvPr/>
+        </p:nvSpPr>
+        <p:spPr>
+          <a:xfrm>
+            <a:off x="502920" y="3163824"/>
+            <a:ext cx="329184" cy="329184"/>
+          </a:xfrm>
+          <a:prstGeom prst="rect">
+            <a:avLst/>
+          </a:prstGeom>
+          <a:noFill/>
+          <a:ln/>
+        </p:spPr>
+        <p:txBody>
+          <a:bodyPr wrap="square" lIns="0" tIns="0" rIns="0" bIns="0" rtlCol="0" anchor="ctr"/>
+          <a:lstStyle/>
+          <a:p>
+            <a:pPr marL="0" indent="0" algn="ctr">
+              <a:buNone/>
+            </a:pPr>
+            <a:r>
+              <a:rPr lang="en-US" sz="1300" b="1" dirty="0">
+                <a:solidFill>
+                  <a:srgbClr val="FFFFFF"/>
+                </a:solidFill>
+              </a:rPr>
+              <a:t>4</a:t>
+            </a:r>
+            <a:endParaRPr lang="en-US" sz="1300" dirty="0"/>
+          </a:p>
+        </p:txBody>
+      </p:sp>
+      <p:sp>
+        <p:nvSpPr>
+          <p:cNvPr id="15" name="Text 13"/>
+          <p:cNvSpPr txBox="1"/>
+          <p:nvPr/>
+        </p:nvSpPr>
+        <p:spPr>
+          <a:xfrm>
+            <a:off x="978408" y="3108960"/>
+            <a:ext cx="3364992" cy="621792"/>
+          </a:xfrm>
+          <a:prstGeom prst="rect">
+            <a:avLst/>
+          </a:prstGeom>
+          <a:noFill/>
+          <a:ln/>
+        </p:spPr>
+        <p:txBody>
+          <a:bodyPr wrap="square" lIns="0" tIns="0" rIns="0" bIns="0" rtlCol="0" anchor="t"/>
+          <a:lstStyle/>
+          <a:p>
+            <a:pPr marL="0" indent="0">
+              <a:spcAft>
+                <a:spcPts val="200"/>
+              </a:spcAft>
+              <a:buNone/>
+            </a:pPr>
+            <a:r>
+              <a:rPr lang="en-US" sz="1500" b="1" dirty="0">
+                <a:solidFill>
+                  <a:srgbClr val="1B2A4A"/>
+                </a:solidFill>
+              </a:rPr>
+              <a:t>Strong model for hard steps</a:t>
+            </a:r>
+            <a:endParaRPr lang="en-US" sz="1500" dirty="0"/>
+          </a:p>
+          <a:p>
+            <a:pPr marL="0" indent="0">
+              <a:spcAft>
+                <a:spcPts val="200"/>
+              </a:spcAft>
+              <a:buNone/>
+            </a:pPr>
+            <a:r>
+              <a:rPr lang="en-US" sz="1200" dirty="0">
+                <a:solidFill>
+                  <a:srgbClr val="5F6F80"/>
+                </a:solidFill>
+              </a:rPr>
+              <a:t>e.g. generate with gpt-4o</a:t>
+            </a:r>
+            <a:endParaRPr lang="en-US" sz="1500" dirty="0"/>
+          </a:p>
+        </p:txBody>
+      </p:sp>
+      <p:sp>
+        <p:nvSpPr>
+          <p:cNvPr id="16" name="Shape 14"/>
+          <p:cNvSpPr/>
+          <p:nvPr/>
+        </p:nvSpPr>
+        <p:spPr>
+          <a:xfrm>
+            <a:off x="502920" y="3913632"/>
+            <a:ext cx="3840480" cy="658368"/>
+          </a:xfrm>
+          <a:prstGeom prst="roundRect">
+            <a:avLst>
+              <a:gd name="adj" fmla="val 11111"/>
+            </a:avLst>
+          </a:prstGeom>
+          <a:solidFill>
+            <a:srgbClr val="FBEFE6"/>
+          </a:solidFill>
+          <a:ln w="12700">
+            <a:solidFill>
+              <a:srgbClr val="FBEFE6"/>
+            </a:solidFill>
+            <a:prstDash val="solid"/>
+          </a:ln>
+        </p:spPr>
+      </p:sp>
+      <p:sp>
+        <p:nvSpPr>
+          <p:cNvPr id="17" name="Text 15"/>
+          <p:cNvSpPr txBox="1"/>
+          <p:nvPr/>
+        </p:nvSpPr>
+        <p:spPr>
+          <a:xfrm>
+            <a:off x="667512" y="3913632"/>
+            <a:ext cx="3511296" cy="658368"/>
+          </a:xfrm>
+          <a:prstGeom prst="rect">
+            <a:avLst/>
+          </a:prstGeom>
+          <a:noFill/>
+          <a:ln/>
+        </p:spPr>
+        <p:txBody>
+          <a:bodyPr wrap="square" lIns="0" tIns="0" rIns="0" bIns="0" rtlCol="0" anchor="ctr"/>
+          <a:lstStyle/>
+          <a:p>
+            <a:pPr marL="0" indent="0">
+              <a:buNone/>
+            </a:pPr>
+            <a:r>
+              <a:rPr lang="en-US" sz="1000" b="1" kern="0" spc="200" dirty="0">
+                <a:solidFill>
+                  <a:srgbClr val="D4824A"/>
+                </a:solidFill>
+              </a:rPr>
+              <a:t>KEY POINT  </a:t>
+            </a:r>
+            <a:r>
+              <a:rPr lang="en-US" sz="1300" dirty="0">
+                <a:solidFill>
+                  <a:srgbClr val="1B2A4A"/>
+                </a:solidFill>
+              </a:rPr>
+              <a:t>Optimize with the best model you can afford; deploy the cheapest that's good enough.</a:t>
+            </a:r>
+            <a:endParaRPr lang="en-US" sz="1000" dirty="0"/>
+          </a:p>
+        </p:txBody>
+      </p:sp>
+      <p:sp>
+        <p:nvSpPr>
+          <p:cNvPr id="18" name="Shape 16"/>
+          <p:cNvSpPr/>
+          <p:nvPr/>
+        </p:nvSpPr>
+        <p:spPr>
+          <a:xfrm>
+            <a:off x="4572000" y="1188720"/>
+            <a:ext cx="4069080" cy="3383280"/>
+          </a:xfrm>
+          <a:prstGeom prst="roundRect">
+            <a:avLst>
+              <a:gd name="adj" fmla="val 2162"/>
+            </a:avLst>
+          </a:prstGeom>
+          <a:solidFill>
+            <a:srgbClr val="1B2A4A"/>
+          </a:solidFill>
+          <a:ln w="12700">
+            <a:solidFill>
+              <a:srgbClr val="1B2A4A"/>
+            </a:solidFill>
+            <a:prstDash val="solid"/>
+          </a:ln>
+        </p:spPr>
+      </p:sp>
+      <p:sp>
+        <p:nvSpPr>
+          <p:cNvPr id="19" name="Text 17"/>
+          <p:cNvSpPr txBox="1"/>
+          <p:nvPr/>
+        </p:nvSpPr>
+        <p:spPr>
+          <a:xfrm>
+            <a:off x="4773168" y="1316736"/>
+            <a:ext cx="3666744" cy="292608"/>
+          </a:xfrm>
+          <a:prstGeom prst="rect">
+            <a:avLst/>
+          </a:prstGeom>
+          <a:noFill/>
+          <a:ln/>
+        </p:spPr>
+        <p:txBody>
+          <a:bodyPr wrap="square" lIns="0" tIns="0" rIns="0" bIns="0" rtlCol="0" anchor="ctr"/>
+          <a:lstStyle/>
+          <a:p>
+            <a:pPr marL="0" indent="0">
+              <a:buNone/>
+            </a:pPr>
+            <a:r>
+              <a:rPr lang="en-US" sz="900" b="1" kern="0" spc="200" dirty="0">
+                <a:solidFill>
+                  <a:srgbClr val="D4824A"/>
+                </a:solidFill>
+              </a:rPr>
+              <a:t>EXAMPLE  </a:t>
+            </a:r>
+            <a:r>
+              <a:rPr lang="en-US" sz="1200" b="1" dirty="0">
+                <a:solidFill>
+                  <a:srgbClr val="FFFFFF"/>
+                </a:solidFill>
+              </a:rPr>
+              <a:t>Multi-model pipeline (demo 10)</a:t>
+            </a:r>
+            <a:endParaRPr lang="en-US" sz="900" dirty="0"/>
+          </a:p>
+        </p:txBody>
+      </p:sp>
+      <p:sp>
+        <p:nvSpPr>
+          <p:cNvPr id="20" name="Text 18"/>
+          <p:cNvSpPr txBox="1"/>
+          <p:nvPr/>
+        </p:nvSpPr>
+        <p:spPr>
+          <a:xfrm>
+            <a:off x="4773168" y="1700784"/>
+            <a:ext cx="3703320" cy="2743200"/>
+          </a:xfrm>
+          <a:prstGeom prst="rect">
+            <a:avLst/>
+          </a:prstGeom>
+          <a:noFill/>
+          <a:ln/>
+        </p:spPr>
+        <p:txBody>
+          <a:bodyPr wrap="square" lIns="0" tIns="0" rIns="0" bIns="0" rtlCol="0" anchor="t"/>
+          <a:lstStyle/>
+          <a:p>
+            <a:pPr marL="0" indent="0">
+              <a:lnSpc>
+                <a:spcPct val="100000"/>
+              </a:lnSpc>
+              <a:buNone/>
+            </a:pPr>
+            <a:r>
+              <a:rPr lang="en-US" sz="1000" dirty="0">
+                <a:solidFill>
+                  <a:srgbClr val="E6EDF5"/>
+                </a:solidFill>
+                <a:latin typeface="Consolas" pitchFamily="34" charset="0"/>
+                <a:ea typeface="Consolas" pitchFamily="34" charset="-122"/>
+                <a:cs typeface="Consolas" pitchFamily="34" charset="-120"/>
+              </a:rPr>
+              <a:t>mini  = dspy.LM("openai/gpt-4o-mini")</a:t>
+            </a:r>
+            <a:endParaRPr lang="en-US" sz="1000" dirty="0"/>
+          </a:p>
+          <a:p>
+            <a:pPr marL="0" indent="0">
+              <a:lnSpc>
+                <a:spcPct val="100000"/>
+              </a:lnSpc>
+              <a:buNone/>
+            </a:pPr>
+            <a:r>
+              <a:rPr lang="en-US" sz="1000" dirty="0">
+                <a:solidFill>
+                  <a:srgbClr val="E6EDF5"/>
+                </a:solidFill>
+                <a:latin typeface="Consolas" pitchFamily="34" charset="0"/>
+                <a:ea typeface="Consolas" pitchFamily="34" charset="-122"/>
+                <a:cs typeface="Consolas" pitchFamily="34" charset="-120"/>
+              </a:rPr>
+              <a:t>gpt4o = dspy.LM("openai/gpt-4o")</a:t>
+            </a:r>
+            <a:endParaRPr lang="en-US" sz="1000" dirty="0"/>
+          </a:p>
+          <a:p>
+            <a:pPr marL="0" indent="0">
+              <a:lnSpc>
+                <a:spcPct val="100000"/>
+              </a:lnSpc>
+              <a:buNone/>
+            </a:pPr>
+            <a:r>
+              <a:rPr lang="en-US" sz="1000" dirty="0">
+                <a:solidFill>
+                  <a:srgbClr val="E6EDF5"/>
+                </a:solidFill>
+                <a:latin typeface="Consolas" pitchFamily="34" charset="0"/>
+                <a:ea typeface="Consolas" pitchFamily="34" charset="-122"/>
+                <a:cs typeface="Consolas" pitchFamily="34" charset="-120"/>
+              </a:rPr>
+              <a:t>dspy.configure(lm=mini)   # default</a:t>
+            </a:r>
+            <a:endParaRPr lang="en-US" sz="1000" dirty="0"/>
+          </a:p>
+          <a:p>
+            <a:pPr marL="0" indent="0">
+              <a:lnSpc>
+                <a:spcPct val="100000"/>
+              </a:lnSpc>
+              <a:buNone/>
+            </a:pPr>
+            <a:endParaRPr lang="en-US" sz="1000" dirty="0"/>
+          </a:p>
+          <a:p>
+            <a:pPr marL="0" indent="0">
+              <a:lnSpc>
+                <a:spcPct val="100000"/>
+              </a:lnSpc>
+              <a:buNone/>
+            </a:pPr>
+            <a:r>
+              <a:rPr lang="en-US" sz="1000" dirty="0">
+                <a:solidFill>
+                  <a:srgbClr val="E6EDF5"/>
+                </a:solidFill>
+                <a:latin typeface="Consolas" pitchFamily="34" charset="0"/>
+                <a:ea typeface="Consolas" pitchFamily="34" charset="-122"/>
+                <a:cs typeface="Consolas" pitchFamily="34" charset="-120"/>
+              </a:rPr>
+              <a:t>class Pipeline(dspy.Module):</a:t>
+            </a:r>
+            <a:endParaRPr lang="en-US" sz="1000" dirty="0"/>
+          </a:p>
+          <a:p>
+            <a:pPr marL="0" indent="0">
+              <a:lnSpc>
+                <a:spcPct val="100000"/>
+              </a:lnSpc>
+              <a:buNone/>
+            </a:pPr>
+            <a:r>
+              <a:rPr lang="en-US" sz="1000" dirty="0">
+                <a:solidFill>
+                  <a:srgbClr val="E6EDF5"/>
+                </a:solidFill>
+                <a:latin typeface="Consolas" pitchFamily="34" charset="0"/>
+                <a:ea typeface="Consolas" pitchFamily="34" charset="-122"/>
+                <a:cs typeface="Consolas" pitchFamily="34" charset="-120"/>
+              </a:rPr>
+              <a:t>    def __init__(self):</a:t>
+            </a:r>
+            <a:endParaRPr lang="en-US" sz="1000" dirty="0"/>
+          </a:p>
+          <a:p>
+            <a:pPr marL="0" indent="0">
+              <a:lnSpc>
+                <a:spcPct val="100000"/>
+              </a:lnSpc>
+              <a:buNone/>
+            </a:pPr>
+            <a:r>
+              <a:rPr lang="en-US" sz="1000" dirty="0">
+                <a:solidFill>
+                  <a:srgbClr val="E6EDF5"/>
+                </a:solidFill>
+                <a:latin typeface="Consolas" pitchFamily="34" charset="0"/>
+                <a:ea typeface="Consolas" pitchFamily="34" charset="-122"/>
+                <a:cs typeface="Consolas" pitchFamily="34" charset="-120"/>
+              </a:rPr>
+              <a:t>        self.classify = dspy.Predict(Intent)</a:t>
+            </a:r>
+            <a:endParaRPr lang="en-US" sz="1000" dirty="0"/>
+          </a:p>
+          <a:p>
+            <a:pPr marL="0" indent="0">
+              <a:lnSpc>
+                <a:spcPct val="100000"/>
+              </a:lnSpc>
+              <a:buNone/>
+            </a:pPr>
+            <a:r>
+              <a:rPr lang="en-US" sz="1000" dirty="0">
+                <a:solidFill>
+                  <a:srgbClr val="E6EDF5"/>
+                </a:solidFill>
+                <a:latin typeface="Consolas" pitchFamily="34" charset="0"/>
+                <a:ea typeface="Consolas" pitchFamily="34" charset="-122"/>
+                <a:cs typeface="Consolas" pitchFamily="34" charset="-120"/>
+              </a:rPr>
+              <a:t>        self.generate = dspy.ChainOfThought(</a:t>
+            </a:r>
+            <a:endParaRPr lang="en-US" sz="1000" dirty="0"/>
+          </a:p>
+          <a:p>
+            <a:pPr marL="0" indent="0">
+              <a:lnSpc>
+                <a:spcPct val="100000"/>
+              </a:lnSpc>
+              <a:buNone/>
+            </a:pPr>
+            <a:r>
+              <a:rPr lang="en-US" sz="1000" dirty="0">
+                <a:solidFill>
+                  <a:srgbClr val="E6EDF5"/>
+                </a:solidFill>
+                <a:latin typeface="Consolas" pitchFamily="34" charset="0"/>
+                <a:ea typeface="Consolas" pitchFamily="34" charset="-122"/>
+                <a:cs typeface="Consolas" pitchFamily="34" charset="-120"/>
+              </a:rPr>
+              <a:t>            Response)</a:t>
+            </a:r>
+            <a:endParaRPr lang="en-US" sz="1000" dirty="0"/>
+          </a:p>
+          <a:p>
+            <a:pPr marL="0" indent="0">
+              <a:lnSpc>
+                <a:spcPct val="100000"/>
+              </a:lnSpc>
+              <a:buNone/>
+            </a:pPr>
+            <a:endParaRPr lang="en-US" sz="1000" dirty="0"/>
+          </a:p>
+          <a:p>
+            <a:pPr marL="0" indent="0">
+              <a:lnSpc>
+                <a:spcPct val="100000"/>
+              </a:lnSpc>
+              <a:buNone/>
+            </a:pPr>
+            <a:r>
+              <a:rPr lang="en-US" sz="1000" dirty="0">
+                <a:solidFill>
+                  <a:srgbClr val="E6EDF5"/>
+                </a:solidFill>
+                <a:latin typeface="Consolas" pitchFamily="34" charset="0"/>
+                <a:ea typeface="Consolas" pitchFamily="34" charset="-122"/>
+                <a:cs typeface="Consolas" pitchFamily="34" charset="-120"/>
+              </a:rPr>
+              <a:t>    def forward(self, query):</a:t>
+            </a:r>
+            <a:endParaRPr lang="en-US" sz="1000" dirty="0"/>
+          </a:p>
+          <a:p>
+            <a:pPr marL="0" indent="0">
+              <a:lnSpc>
+                <a:spcPct val="100000"/>
+              </a:lnSpc>
+              <a:buNone/>
+            </a:pPr>
+            <a:r>
+              <a:rPr lang="en-US" sz="1000" dirty="0">
+                <a:solidFill>
+                  <a:srgbClr val="E6EDF5"/>
+                </a:solidFill>
+                <a:latin typeface="Consolas" pitchFamily="34" charset="0"/>
+                <a:ea typeface="Consolas" pitchFamily="34" charset="-122"/>
+                <a:cs typeface="Consolas" pitchFamily="34" charset="-120"/>
+              </a:rPr>
+              <a:t>        intent = self.classify(query=query)</a:t>
+            </a:r>
+            <a:endParaRPr lang="en-US" sz="1000" dirty="0"/>
+          </a:p>
+          <a:p>
+            <a:pPr marL="0" indent="0">
+              <a:lnSpc>
+                <a:spcPct val="100000"/>
+              </a:lnSpc>
+              <a:buNone/>
+            </a:pPr>
+            <a:r>
+              <a:rPr lang="en-US" sz="1000" dirty="0">
+                <a:solidFill>
+                  <a:srgbClr val="E6EDF5"/>
+                </a:solidFill>
+                <a:latin typeface="Consolas" pitchFamily="34" charset="0"/>
+                <a:ea typeface="Consolas" pitchFamily="34" charset="-122"/>
+                <a:cs typeface="Consolas" pitchFamily="34" charset="-120"/>
+              </a:rPr>
+              <a:t>        with dspy.context(lm=gpt4o):</a:t>
+            </a:r>
+            <a:endParaRPr lang="en-US" sz="1000" dirty="0"/>
+          </a:p>
+          <a:p>
+            <a:pPr marL="0" indent="0">
+              <a:lnSpc>
+                <a:spcPct val="100000"/>
+              </a:lnSpc>
+              <a:buNone/>
+            </a:pPr>
+            <a:r>
+              <a:rPr lang="en-US" sz="1000" dirty="0">
+                <a:solidFill>
+                  <a:srgbClr val="E6EDF5"/>
+                </a:solidFill>
+                <a:latin typeface="Consolas" pitchFamily="34" charset="0"/>
+                <a:ea typeface="Consolas" pitchFamily="34" charset="-122"/>
+                <a:cs typeface="Consolas" pitchFamily="34" charset="-120"/>
+              </a:rPr>
+              <a:t>            return self.generate(query=query,</a:t>
+            </a:r>
+            <a:endParaRPr lang="en-US" sz="1000" dirty="0"/>
+          </a:p>
+          <a:p>
+            <a:pPr marL="0" indent="0">
+              <a:lnSpc>
+                <a:spcPct val="100000"/>
+              </a:lnSpc>
+              <a:buNone/>
+            </a:pPr>
+            <a:r>
+              <a:rPr lang="en-US" sz="1000" dirty="0">
+                <a:solidFill>
+                  <a:srgbClr val="E6EDF5"/>
+                </a:solidFill>
+                <a:latin typeface="Consolas" pitchFamily="34" charset="0"/>
+                <a:ea typeface="Consolas" pitchFamily="34" charset="-122"/>
+                <a:cs typeface="Consolas" pitchFamily="34" charset="-120"/>
+              </a:rPr>
+              <a:t>                intent=intent.category)</a:t>
+            </a:r>
+            <a:endParaRPr lang="en-US" sz="1000" dirty="0"/>
+          </a:p>
+        </p:txBody>
+      </p:sp>
+      <p:sp>
+        <p:nvSpPr>
+          <p:cNvPr id="25" name="Slide Number Placeholder 0"/>
+          <p:cNvSpPr>
+            <a:spLocks noGrp="1"/>
+          </p:cNvSpPr>
+          <p:nvPr>
+            <p:ph type="sldNum" sz="quarter" idx="4294967295"/>
+          </p:nvPr>
+        </p:nvSpPr>
+        <p:spPr>
+          <a:xfrm>
+            <a:off x="8229600" y="4800600"/>
+            <a:ext cx="411480" cy="228600"/>
+          </a:xfrm>
+          <a:prstGeom prst="rect">
+            <a:avLst/>
+          </a:prstGeom>
+          <a:extLst>
+            <a:ext uri="{C572A759-6A51-4108-AA02-DFA0A04FC94B}">
+              <ma14:wrappingTextBoxFlag xmlns="" xmlns:ma14="http://schemas.microsoft.com/office/mac/drawingml/2011/main" val="0"/>
+            </a:ext>
+          </a:extLst>
+        </p:spPr>
+        <p:txBody>
+          <a:bodyPr/>
+          <a:lstStyle>
+            <a:lvl1pPr>
+              <a:defRPr sz="900">
+                <a:solidFill>
+                  <a:srgbClr val="A0B0C0"/>
+                </a:solidFill>
+              </a:defRPr>
+            </a:lvl1pPr>
+          </a:lstStyle>
+          <a:p>
+            <a:pPr algn="r"/>
+            <a:fld id="{F7021451-1387-4CA6-816F-3879F97B5CBC}" type="slidenum">
+              <a:rPr lang="en-US" b="0"/>
+              <a:t>20</a:t>
+            </a:fld>
+            <a:endParaRPr lang="en-US"/>
+          </a:p>
+        </p:txBody>
+      </p:sp>
+    </p:spTree>
+  </p:cSld>
+  <p:clrMapOvr>
+    <a:masterClrMapping/>
+  </p:clrMapOvr>
+</p:sld>
+</file>
+
+<file path=ppt/slides/slide21.xml><?xml version="1.0" encoding="utf-8"?>
 <p:sld xmlns:a="http://schemas.openxmlformats.org/drawingml/2006/main" xmlns:r="http://schemas.openxmlformats.org/officeDocument/2006/relationships" xmlns:p="http://schemas.openxmlformats.org/presentationml/2006/main">
   <p:cSld name="Slide 20">
     <p:spTree>
@@ -15877,7 +16650,7 @@
           </a:prstGeom>
           <a:extLst>
             <a:ext uri="{C572A759-6A51-4108-AA02-DFA0A04FC94B}">
-              <ma14:wrappingTextBoxFlag xmlns:ma14="http://schemas.microsoft.com/office/mac/drawingml/2011/main" xmlns="" val="0"/>
+              <ma14:wrappingTextBoxFlag xmlns="" xmlns:ma14="http://schemas.microsoft.com/office/mac/drawingml/2011/main" val="0"/>
             </a:ext>
           </a:extLst>
         </p:spPr>
@@ -15896,7 +16669,7 @@
             <a:pPr algn="r"/>
             <a:fld id="{F7021451-1387-4CA6-816F-3879F97B5CBC}" type="slidenum">
               <a:rPr lang="en-US" b="0"/>
-              <a:t>20</a:t>
+              <a:t>21</a:t>
             </a:fld>
             <a:endParaRPr lang="en-US"/>
           </a:p>
@@ -15910,7 +16683,7 @@
 </p:sld>
 </file>
 
-<file path=ppt/slides/slide21.xml><?xml version="1.0" encoding="utf-8"?>
+<file path=ppt/slides/slide22.xml><?xml version="1.0" encoding="utf-8"?>
 <p:sld xmlns:a="http://schemas.openxmlformats.org/drawingml/2006/main" xmlns:r="http://schemas.openxmlformats.org/officeDocument/2006/relationships" xmlns:p="http://schemas.openxmlformats.org/presentationml/2006/main">
   <p:cSld name="Slide 21">
     <p:spTree>
@@ -16898,7 +17671,7 @@
           </a:prstGeom>
           <a:extLst>
             <a:ext uri="{C572A759-6A51-4108-AA02-DFA0A04FC94B}">
-              <ma14:wrappingTextBoxFlag xmlns:ma14="http://schemas.microsoft.com/office/mac/drawingml/2011/main" xmlns="" val="0"/>
+              <ma14:wrappingTextBoxFlag xmlns="" xmlns:ma14="http://schemas.microsoft.com/office/mac/drawingml/2011/main" val="0"/>
             </a:ext>
           </a:extLst>
         </p:spPr>
@@ -16917,7 +17690,7 @@
             <a:pPr algn="r"/>
             <a:fld id="{F7021451-1387-4CA6-816F-3879F97B5CBC}" type="slidenum">
               <a:rPr lang="en-US" b="0"/>
-              <a:t>21</a:t>
+              <a:t>22</a:t>
             </a:fld>
             <a:endParaRPr lang="en-US"/>
           </a:p>
@@ -16931,7 +17704,7 @@
 </p:sld>
 </file>
 
-<file path=ppt/slides/slide22.xml><?xml version="1.0" encoding="utf-8"?>
+<file path=ppt/slides/slide23.xml><?xml version="1.0" encoding="utf-8"?>
 <p:sld xmlns:a="http://schemas.openxmlformats.org/drawingml/2006/main" xmlns:r="http://schemas.openxmlformats.org/officeDocument/2006/relationships" xmlns:p="http://schemas.openxmlformats.org/presentationml/2006/main">
   <p:cSld name="Slide 22">
     <p:spTree>
@@ -17894,7 +18667,7 @@
           </a:prstGeom>
           <a:extLst>
             <a:ext uri="{C572A759-6A51-4108-AA02-DFA0A04FC94B}">
-              <ma14:wrappingTextBoxFlag xmlns:ma14="http://schemas.microsoft.com/office/mac/drawingml/2011/main" xmlns="" val="0"/>
+              <ma14:wrappingTextBoxFlag xmlns="" xmlns:ma14="http://schemas.microsoft.com/office/mac/drawingml/2011/main" val="0"/>
             </a:ext>
           </a:extLst>
         </p:spPr>
@@ -17913,7 +18686,7 @@
             <a:pPr algn="r"/>
             <a:fld id="{F7021451-1387-4CA6-816F-3879F97B5CBC}" type="slidenum">
               <a:rPr lang="en-US" b="0"/>
-              <a:t>22</a:t>
+              <a:t>23</a:t>
             </a:fld>
             <a:endParaRPr lang="en-US"/>
           </a:p>
@@ -17927,7 +18700,7 @@
 </p:sld>
 </file>
 
-<file path=ppt/slides/slide23.xml><?xml version="1.0" encoding="utf-8"?>
+<file path=ppt/slides/slide24.xml><?xml version="1.0" encoding="utf-8"?>
 <p:sld xmlns:a="http://schemas.openxmlformats.org/drawingml/2006/main" xmlns:r="http://schemas.openxmlformats.org/officeDocument/2006/relationships" xmlns:p="http://schemas.openxmlformats.org/presentationml/2006/main">
   <p:cSld name="Slide 23">
     <p:spTree>
@@ -18957,7 +19730,7 @@
           </a:prstGeom>
           <a:extLst>
             <a:ext uri="{C572A759-6A51-4108-AA02-DFA0A04FC94B}">
-              <ma14:wrappingTextBoxFlag xmlns:ma14="http://schemas.microsoft.com/office/mac/drawingml/2011/main" xmlns="" val="0"/>
+              <ma14:wrappingTextBoxFlag xmlns="" xmlns:ma14="http://schemas.microsoft.com/office/mac/drawingml/2011/main" val="0"/>
             </a:ext>
           </a:extLst>
         </p:spPr>
@@ -18976,7 +19749,7 @@
             <a:pPr algn="r"/>
             <a:fld id="{F7021451-1387-4CA6-816F-3879F97B5CBC}" type="slidenum">
               <a:rPr lang="en-US" b="0"/>
-              <a:t>23</a:t>
+              <a:t>24</a:t>
             </a:fld>
             <a:endParaRPr lang="en-US"/>
           </a:p>
@@ -18990,7 +19763,7 @@
 </p:sld>
 </file>
 
-<file path=ppt/slides/slide24.xml><?xml version="1.0" encoding="utf-8"?>
+<file path=ppt/slides/slide25.xml><?xml version="1.0" encoding="utf-8"?>
 <p:sld xmlns:a="http://schemas.openxmlformats.org/drawingml/2006/main" xmlns:r="http://schemas.openxmlformats.org/officeDocument/2006/relationships" xmlns:p="http://schemas.openxmlformats.org/presentationml/2006/main">
   <p:cSld name="Slide 24">
     <p:spTree>
@@ -19703,7 +20476,7 @@
           </a:prstGeom>
           <a:extLst>
             <a:ext uri="{C572A759-6A51-4108-AA02-DFA0A04FC94B}">
-              <ma14:wrappingTextBoxFlag xmlns:ma14="http://schemas.microsoft.com/office/mac/drawingml/2011/main" xmlns="" val="0"/>
+              <ma14:wrappingTextBoxFlag xmlns="" xmlns:ma14="http://schemas.microsoft.com/office/mac/drawingml/2011/main" val="0"/>
             </a:ext>
           </a:extLst>
         </p:spPr>
@@ -19722,7 +20495,7 @@
             <a:pPr algn="r"/>
             <a:fld id="{F7021451-1387-4CA6-816F-3879F97B5CBC}" type="slidenum">
               <a:rPr lang="en-US" b="0"/>
-              <a:t>24</a:t>
+              <a:t>25</a:t>
             </a:fld>
             <a:endParaRPr lang="en-US"/>
           </a:p>
@@ -19736,7 +20509,7 @@
 </p:sld>
 </file>
 
-<file path=ppt/slides/slide25.xml><?xml version="1.0" encoding="utf-8"?>
+<file path=ppt/slides/slide26.xml><?xml version="1.0" encoding="utf-8"?>
 <p:sld xmlns:a="http://schemas.openxmlformats.org/drawingml/2006/main" xmlns:r="http://schemas.openxmlformats.org/officeDocument/2006/relationships" xmlns:p="http://schemas.openxmlformats.org/presentationml/2006/main">
   <p:cSld name="Slide 25">
     <p:spTree>
@@ -21289,7 +22062,7 @@
           </a:prstGeom>
           <a:extLst>
             <a:ext uri="{C572A759-6A51-4108-AA02-DFA0A04FC94B}">
-              <ma14:wrappingTextBoxFlag xmlns:ma14="http://schemas.microsoft.com/office/mac/drawingml/2011/main" xmlns="" val="0"/>
+              <ma14:wrappingTextBoxFlag xmlns="" xmlns:ma14="http://schemas.microsoft.com/office/mac/drawingml/2011/main" val="0"/>
             </a:ext>
           </a:extLst>
         </p:spPr>
@@ -21323,6 +22096,66 @@
 </file>
 
 <file path=ppt/slides/slide4.xml><?xml version="1.0" encoding="utf-8"?>
+<p:sld xmlns:a="http://schemas.openxmlformats.org/drawingml/2006/main" xmlns:r="http://schemas.openxmlformats.org/officeDocument/2006/relationships" xmlns:p="http://schemas.openxmlformats.org/presentationml/2006/main">
+  <p:cSld>
+    <p:spTree>
+      <p:nvGrpSpPr>
+        <p:cNvPr id="1" name=""/>
+        <p:cNvGrpSpPr/>
+        <p:nvPr/>
+      </p:nvGrpSpPr>
+      <p:grpSpPr>
+        <a:xfrm>
+          <a:off x="0" y="0"/>
+          <a:ext cx="0" cy="0"/>
+          <a:chOff x="0" y="0"/>
+          <a:chExt cx="0" cy="0"/>
+        </a:xfrm>
+      </p:grpSpPr>
+      <p:pic>
+        <p:nvPicPr>
+          <p:cNvPr id="4" name="Picture 3">
+            <a:extLst>
+              <a:ext uri="{FF2B5EF4-FFF2-40B4-BE49-F238E27FC236}">
+                <a16:creationId xmlns:a16="http://schemas.microsoft.com/office/drawing/2014/main" id="{C6A1419A-49BE-7238-C552-84D5EFF5E731}"/>
+              </a:ext>
+            </a:extLst>
+          </p:cNvPr>
+          <p:cNvPicPr>
+            <a:picLocks noChangeAspect="1"/>
+          </p:cNvPicPr>
+          <p:nvPr/>
+        </p:nvPicPr>
+        <p:blipFill>
+          <a:blip r:embed="rId2"/>
+          <a:stretch>
+            <a:fillRect/>
+          </a:stretch>
+        </p:blipFill>
+        <p:spPr>
+          <a:xfrm>
+            <a:off x="0" y="285750"/>
+            <a:ext cx="9144000" cy="4572000"/>
+          </a:xfrm>
+          <a:prstGeom prst="rect">
+            <a:avLst/>
+          </a:prstGeom>
+        </p:spPr>
+      </p:pic>
+    </p:spTree>
+    <p:extLst>
+      <p:ext uri="{BB962C8B-B14F-4D97-AF65-F5344CB8AC3E}">
+        <p14:creationId xmlns:p14="http://schemas.microsoft.com/office/powerpoint/2010/main" val="2634527700"/>
+      </p:ext>
+    </p:extLst>
+  </p:cSld>
+  <p:clrMapOvr>
+    <a:masterClrMapping/>
+  </p:clrMapOvr>
+</p:sld>
+</file>
+
+<file path=ppt/slides/slide5.xml><?xml version="1.0" encoding="utf-8"?>
 <p:sld xmlns:a="http://schemas.openxmlformats.org/drawingml/2006/main" xmlns:r="http://schemas.openxmlformats.org/officeDocument/2006/relationships" xmlns:p="http://schemas.openxmlformats.org/presentationml/2006/main">
   <p:cSld name="Slide 4">
     <p:spTree>
@@ -22390,7 +23223,7 @@
           </a:prstGeom>
           <a:extLst>
             <a:ext uri="{C572A759-6A51-4108-AA02-DFA0A04FC94B}">
-              <ma14:wrappingTextBoxFlag xmlns:ma14="http://schemas.microsoft.com/office/mac/drawingml/2011/main" xmlns="" val="0"/>
+              <ma14:wrappingTextBoxFlag xmlns="" xmlns:ma14="http://schemas.microsoft.com/office/mac/drawingml/2011/main" val="0"/>
             </a:ext>
           </a:extLst>
         </p:spPr>
@@ -22409,7 +23242,7 @@
             <a:pPr algn="r"/>
             <a:fld id="{F7021451-1387-4CA6-816F-3879F97B5CBC}" type="slidenum">
               <a:rPr lang="en-US" b="0"/>
-              <a:t>4</a:t>
+              <a:t>5</a:t>
             </a:fld>
             <a:endParaRPr lang="en-US"/>
           </a:p>
@@ -22423,7 +23256,7 @@
 </p:sld>
 </file>
 
-<file path=ppt/slides/slide5.xml><?xml version="1.0" encoding="utf-8"?>
+<file path=ppt/slides/slide6.xml><?xml version="1.0" encoding="utf-8"?>
 <p:sld xmlns:a="http://schemas.openxmlformats.org/drawingml/2006/main" xmlns:r="http://schemas.openxmlformats.org/officeDocument/2006/relationships" xmlns:p="http://schemas.openxmlformats.org/presentationml/2006/main">
   <p:cSld name="Slide 5">
     <p:spTree>
@@ -23121,7 +23954,7 @@
           </a:prstGeom>
           <a:extLst>
             <a:ext uri="{C572A759-6A51-4108-AA02-DFA0A04FC94B}">
-              <ma14:wrappingTextBoxFlag xmlns:ma14="http://schemas.microsoft.com/office/mac/drawingml/2011/main" xmlns="" val="0"/>
+              <ma14:wrappingTextBoxFlag xmlns="" xmlns:ma14="http://schemas.microsoft.com/office/mac/drawingml/2011/main" val="0"/>
             </a:ext>
           </a:extLst>
         </p:spPr>
@@ -23140,7 +23973,7 @@
             <a:pPr algn="r"/>
             <a:fld id="{F7021451-1387-4CA6-816F-3879F97B5CBC}" type="slidenum">
               <a:rPr lang="en-US" b="0"/>
-              <a:t>5</a:t>
+              <a:t>6</a:t>
             </a:fld>
             <a:endParaRPr lang="en-US"/>
           </a:p>
@@ -23154,7 +23987,7 @@
 </p:sld>
 </file>
 
-<file path=ppt/slides/slide6.xml><?xml version="1.0" encoding="utf-8"?>
+<file path=ppt/slides/slide7.xml><?xml version="1.0" encoding="utf-8"?>
 <p:sld xmlns:a="http://schemas.openxmlformats.org/drawingml/2006/main" xmlns:r="http://schemas.openxmlformats.org/officeDocument/2006/relationships" xmlns:p="http://schemas.openxmlformats.org/presentationml/2006/main">
   <p:cSld name="Slide 6">
     <p:spTree>
@@ -24117,7 +24950,7 @@
           </a:prstGeom>
           <a:extLst>
             <a:ext uri="{C572A759-6A51-4108-AA02-DFA0A04FC94B}">
-              <ma14:wrappingTextBoxFlag xmlns:ma14="http://schemas.microsoft.com/office/mac/drawingml/2011/main" xmlns="" val="0"/>
+              <ma14:wrappingTextBoxFlag xmlns="" xmlns:ma14="http://schemas.microsoft.com/office/mac/drawingml/2011/main" val="0"/>
             </a:ext>
           </a:extLst>
         </p:spPr>
@@ -24136,7 +24969,7 @@
             <a:pPr algn="r"/>
             <a:fld id="{F7021451-1387-4CA6-816F-3879F97B5CBC}" type="slidenum">
               <a:rPr lang="en-US" b="0"/>
-              <a:t>6</a:t>
+              <a:t>7</a:t>
             </a:fld>
             <a:endParaRPr lang="en-US"/>
           </a:p>
@@ -24150,7 +24983,7 @@
 </p:sld>
 </file>
 
-<file path=ppt/slides/slide7.xml><?xml version="1.0" encoding="utf-8"?>
+<file path=ppt/slides/slide8.xml><?xml version="1.0" encoding="utf-8"?>
 <p:sld xmlns:a="http://schemas.openxmlformats.org/drawingml/2006/main" xmlns:r="http://schemas.openxmlformats.org/officeDocument/2006/relationships" xmlns:p="http://schemas.openxmlformats.org/presentationml/2006/main">
   <p:cSld name="Slide 7">
     <p:spTree>
@@ -24872,7 +25705,7 @@
           </a:prstGeom>
           <a:extLst>
             <a:ext uri="{C572A759-6A51-4108-AA02-DFA0A04FC94B}">
-              <ma14:wrappingTextBoxFlag xmlns:ma14="http://schemas.microsoft.com/office/mac/drawingml/2011/main" xmlns="" val="0"/>
+              <ma14:wrappingTextBoxFlag xmlns="" xmlns:ma14="http://schemas.microsoft.com/office/mac/drawingml/2011/main" val="0"/>
             </a:ext>
           </a:extLst>
         </p:spPr>
@@ -24891,7 +25724,7 @@
             <a:pPr algn="r"/>
             <a:fld id="{F7021451-1387-4CA6-816F-3879F97B5CBC}" type="slidenum">
               <a:rPr lang="en-US" b="0"/>
-              <a:t>7</a:t>
+              <a:t>8</a:t>
             </a:fld>
             <a:endParaRPr lang="en-US"/>
           </a:p>
@@ -24905,7 +25738,7 @@
 </p:sld>
 </file>
 
-<file path=ppt/slides/slide8.xml><?xml version="1.0" encoding="utf-8"?>
+<file path=ppt/slides/slide9.xml><?xml version="1.0" encoding="utf-8"?>
 <p:sld xmlns:a="http://schemas.openxmlformats.org/drawingml/2006/main" xmlns:r="http://schemas.openxmlformats.org/officeDocument/2006/relationships" xmlns:p="http://schemas.openxmlformats.org/presentationml/2006/main">
   <p:cSld name="Slide 8">
     <p:spTree>
@@ -25928,779 +26761,7 @@
           </a:prstGeom>
           <a:extLst>
             <a:ext uri="{C572A759-6A51-4108-AA02-DFA0A04FC94B}">
-              <ma14:wrappingTextBoxFlag xmlns:ma14="http://schemas.microsoft.com/office/mac/drawingml/2011/main" xmlns="" val="0"/>
-            </a:ext>
-          </a:extLst>
-        </p:spPr>
-        <p:txBody>
-          <a:bodyPr/>
-          <a:lstStyle>
-            <a:lvl1pPr>
-              <a:defRPr sz="900">
-                <a:solidFill>
-                  <a:srgbClr val="A0B0C0"/>
-                </a:solidFill>
-              </a:defRPr>
-            </a:lvl1pPr>
-          </a:lstStyle>
-          <a:p>
-            <a:pPr algn="r"/>
-            <a:fld id="{F7021451-1387-4CA6-816F-3879F97B5CBC}" type="slidenum">
-              <a:rPr lang="en-US" b="0"/>
-              <a:t>8</a:t>
-            </a:fld>
-            <a:endParaRPr lang="en-US"/>
-          </a:p>
-        </p:txBody>
-      </p:sp>
-    </p:spTree>
-  </p:cSld>
-  <p:clrMapOvr>
-    <a:masterClrMapping/>
-  </p:clrMapOvr>
-</p:sld>
-</file>
-
-<file path=ppt/slides/slide9.xml><?xml version="1.0" encoding="utf-8"?>
-<p:sld xmlns:a="http://schemas.openxmlformats.org/drawingml/2006/main" xmlns:r="http://schemas.openxmlformats.org/officeDocument/2006/relationships" xmlns:p="http://schemas.openxmlformats.org/presentationml/2006/main">
-  <p:cSld name="Slide 9">
-    <p:spTree>
-      <p:nvGrpSpPr>
-        <p:cNvPr id="1" name=""/>
-        <p:cNvGrpSpPr/>
-        <p:nvPr/>
-      </p:nvGrpSpPr>
-      <p:grpSpPr>
-        <a:xfrm>
-          <a:off x="0" y="0"/>
-          <a:ext cx="0" cy="0"/>
-          <a:chOff x="0" y="0"/>
-          <a:chExt cx="0" cy="0"/>
-        </a:xfrm>
-      </p:grpSpPr>
-      <p:sp>
-        <p:nvSpPr>
-          <p:cNvPr id="2" name="Text 0"/>
-          <p:cNvSpPr txBox="1"/>
-          <p:nvPr/>
-        </p:nvSpPr>
-        <p:spPr>
-          <a:xfrm>
-            <a:off x="502920" y="201168"/>
-            <a:ext cx="8138160" cy="256032"/>
-          </a:xfrm>
-          <a:prstGeom prst="rect">
-            <a:avLst/>
-          </a:prstGeom>
-          <a:noFill/>
-          <a:ln/>
-        </p:spPr>
-        <p:txBody>
-          <a:bodyPr wrap="square" lIns="0" tIns="0" rIns="0" bIns="0" rtlCol="0" anchor="ctr"/>
-          <a:lstStyle/>
-          <a:p>
-            <a:pPr marL="0" indent="0">
-              <a:buNone/>
-            </a:pPr>
-            <a:r>
-              <a:rPr lang="en-US" sz="1000" b="1" kern="0" spc="300" dirty="0">
-                <a:solidFill>
-                  <a:srgbClr val="D4824A"/>
-                </a:solidFill>
-              </a:rPr>
-              <a:t>DSPY FUNDAMENTALS  ·  7 OF 7</a:t>
-            </a:r>
-            <a:endParaRPr lang="en-US" sz="1000" dirty="0"/>
-          </a:p>
-        </p:txBody>
-      </p:sp>
-      <p:sp>
-        <p:nvSpPr>
-          <p:cNvPr id="3" name="Text 1"/>
-          <p:cNvSpPr>
-            <a:spLocks noGrp="1"/>
-          </p:cNvSpPr>
-          <p:nvPr>
-            <p:ph type="title" idx="101" hasCustomPrompt="1"/>
-          </p:nvPr>
-        </p:nvSpPr>
-        <p:spPr>
-          <a:xfrm>
-            <a:off x="502920" y="457200"/>
-            <a:ext cx="8138160" cy="594360"/>
-          </a:xfrm>
-          <a:prstGeom prst="rect">
-            <a:avLst/>
-          </a:prstGeom>
-          <a:noFill/>
-          <a:ln/>
-        </p:spPr>
-        <p:txBody>
-          <a:bodyPr wrap="square" lIns="0" tIns="0" rIns="0" bIns="0" rtlCol="0" anchor="ctr"/>
-          <a:lstStyle/>
-          <a:p>
-            <a:pPr marL="0" indent="0" algn="l">
-              <a:buNone/>
-            </a:pPr>
-            <a:r>
-              <a:rPr lang="en-US" sz="2800" b="1" dirty="0">
-                <a:solidFill>
-                  <a:srgbClr val="1B2A4A"/>
-                </a:solidFill>
-              </a:rPr>
-              <a:t>Predict, ChainOfThought, and ReAct</a:t>
-            </a:r>
-            <a:endParaRPr lang="en-US" sz="2800" dirty="0"/>
-          </a:p>
-        </p:txBody>
-      </p:sp>
-      <p:sp>
-        <p:nvSpPr>
-          <p:cNvPr id="4" name="Shape 2"/>
-          <p:cNvSpPr/>
-          <p:nvPr/>
-        </p:nvSpPr>
-        <p:spPr>
-          <a:xfrm>
-            <a:off x="502920" y="1280160"/>
-            <a:ext cx="2514600" cy="2331720"/>
-          </a:xfrm>
-          <a:prstGeom prst="roundRect">
-            <a:avLst>
-              <a:gd name="adj" fmla="val 3922"/>
-            </a:avLst>
-          </a:prstGeom>
-          <a:solidFill>
-            <a:srgbClr val="F4F6F9"/>
-          </a:solidFill>
-          <a:ln w="12700">
-            <a:solidFill>
-              <a:srgbClr val="F4F6F9"/>
-            </a:solidFill>
-            <a:prstDash val="solid"/>
-          </a:ln>
-        </p:spPr>
-      </p:sp>
-      <p:sp>
-        <p:nvSpPr>
-          <p:cNvPr id="5" name="Shape 3"/>
-          <p:cNvSpPr/>
-          <p:nvPr/>
-        </p:nvSpPr>
-        <p:spPr>
-          <a:xfrm>
-            <a:off x="502920" y="1280160"/>
-            <a:ext cx="2514600" cy="548640"/>
-          </a:xfrm>
-          <a:prstGeom prst="roundRect">
-            <a:avLst>
-              <a:gd name="adj" fmla="val 16667"/>
-            </a:avLst>
-          </a:prstGeom>
-          <a:solidFill>
-            <a:srgbClr val="1B2A4A"/>
-          </a:solidFill>
-          <a:ln w="12700">
-            <a:solidFill>
-              <a:srgbClr val="1B2A4A"/>
-            </a:solidFill>
-            <a:prstDash val="solid"/>
-          </a:ln>
-        </p:spPr>
-      </p:sp>
-      <p:sp>
-        <p:nvSpPr>
-          <p:cNvPr id="6" name="Text 4"/>
-          <p:cNvSpPr txBox="1"/>
-          <p:nvPr/>
-        </p:nvSpPr>
-        <p:spPr>
-          <a:xfrm>
-            <a:off x="502920" y="1280160"/>
-            <a:ext cx="2514600" cy="548640"/>
-          </a:xfrm>
-          <a:prstGeom prst="rect">
-            <a:avLst/>
-          </a:prstGeom>
-          <a:noFill/>
-          <a:ln/>
-        </p:spPr>
-        <p:txBody>
-          <a:bodyPr wrap="square" lIns="0" tIns="0" rIns="0" bIns="0" rtlCol="0" anchor="ctr"/>
-          <a:lstStyle/>
-          <a:p>
-            <a:pPr marL="0" indent="0" algn="ctr">
-              <a:buNone/>
-            </a:pPr>
-            <a:r>
-              <a:rPr lang="en-US" sz="1400" b="1" dirty="0">
-                <a:solidFill>
-                  <a:srgbClr val="FFFFFF"/>
-                </a:solidFill>
-                <a:latin typeface="Consolas" pitchFamily="34" charset="0"/>
-                <a:ea typeface="Consolas" pitchFamily="34" charset="-122"/>
-                <a:cs typeface="Consolas" pitchFamily="34" charset="-120"/>
-              </a:rPr>
-              <a:t>dspy.Predict</a:t>
-            </a:r>
-            <a:endParaRPr lang="en-US" sz="1400" dirty="0"/>
-          </a:p>
-        </p:txBody>
-      </p:sp>
-      <p:sp>
-        <p:nvSpPr>
-          <p:cNvPr id="7" name="Text 5"/>
-          <p:cNvSpPr txBox="1"/>
-          <p:nvPr/>
-        </p:nvSpPr>
-        <p:spPr>
-          <a:xfrm>
-            <a:off x="704088" y="1965960"/>
-            <a:ext cx="2112264" cy="1554480"/>
-          </a:xfrm>
-          <a:prstGeom prst="rect">
-            <a:avLst/>
-          </a:prstGeom>
-          <a:noFill/>
-          <a:ln/>
-        </p:spPr>
-        <p:txBody>
-          <a:bodyPr wrap="square" lIns="0" tIns="0" rIns="0" bIns="0" rtlCol="0" anchor="t"/>
-          <a:lstStyle/>
-          <a:p>
-            <a:pPr marL="0" indent="0">
-              <a:buNone/>
-            </a:pPr>
-            <a:r>
-              <a:rPr lang="en-US" sz="950" b="1" kern="0" spc="200" dirty="0">
-                <a:solidFill>
-                  <a:srgbClr val="D4824A"/>
-                </a:solidFill>
-              </a:rPr>
-              <a:t>HOW</a:t>
-            </a:r>
-            <a:endParaRPr lang="en-US" sz="950" dirty="0"/>
-          </a:p>
-          <a:p>
-            <a:pPr marL="0" indent="0">
-              <a:buNone/>
-            </a:pPr>
-            <a:r>
-              <a:rPr lang="en-US" sz="1400" dirty="0">
-                <a:solidFill>
-                  <a:srgbClr val="1B2A4A"/>
-                </a:solidFill>
-              </a:rPr>
-              <a:t>One LLM call, answer directly</a:t>
-            </a:r>
-            <a:endParaRPr lang="en-US" sz="950" dirty="0"/>
-          </a:p>
-          <a:p>
-            <a:pPr marL="0" indent="0">
-              <a:buNone/>
-            </a:pPr>
-            <a:r>
-              <a:rPr lang="en-US" sz="600" dirty="0">
-                <a:solidFill>
-                  <a:srgbClr val="000000"/>
-                </a:solidFill>
-              </a:rPr>
-              <a:t> </a:t>
-            </a:r>
-            <a:endParaRPr lang="en-US" sz="950" dirty="0"/>
-          </a:p>
-          <a:p>
-            <a:pPr marL="0" indent="0">
-              <a:buNone/>
-            </a:pPr>
-            <a:r>
-              <a:rPr lang="en-US" sz="950" b="1" kern="0" spc="200" dirty="0">
-                <a:solidFill>
-                  <a:srgbClr val="D4824A"/>
-                </a:solidFill>
-              </a:rPr>
-              <a:t>BEST FOR</a:t>
-            </a:r>
-            <a:endParaRPr lang="en-US" sz="950" dirty="0"/>
-          </a:p>
-          <a:p>
-            <a:pPr marL="0" indent="0">
-              <a:buNone/>
-            </a:pPr>
-            <a:r>
-              <a:rPr lang="en-US" sz="1400" dirty="0">
-                <a:solidFill>
-                  <a:srgbClr val="1B2A4A"/>
-                </a:solidFill>
-              </a:rPr>
-              <a:t>Classification, extraction</a:t>
-            </a:r>
-            <a:endParaRPr lang="en-US" sz="950" dirty="0"/>
-          </a:p>
-        </p:txBody>
-      </p:sp>
-      <p:sp>
-        <p:nvSpPr>
-          <p:cNvPr id="8" name="Shape 6"/>
-          <p:cNvSpPr/>
-          <p:nvPr/>
-        </p:nvSpPr>
-        <p:spPr>
-          <a:xfrm>
-            <a:off x="3314700" y="1280160"/>
-            <a:ext cx="2514600" cy="2331720"/>
-          </a:xfrm>
-          <a:prstGeom prst="roundRect">
-            <a:avLst>
-              <a:gd name="adj" fmla="val 3922"/>
-            </a:avLst>
-          </a:prstGeom>
-          <a:solidFill>
-            <a:srgbClr val="F4F6F9"/>
-          </a:solidFill>
-          <a:ln w="12700">
-            <a:solidFill>
-              <a:srgbClr val="F4F6F9"/>
-            </a:solidFill>
-            <a:prstDash val="solid"/>
-          </a:ln>
-        </p:spPr>
-      </p:sp>
-      <p:sp>
-        <p:nvSpPr>
-          <p:cNvPr id="9" name="Shape 7"/>
-          <p:cNvSpPr/>
-          <p:nvPr/>
-        </p:nvSpPr>
-        <p:spPr>
-          <a:xfrm>
-            <a:off x="3314700" y="1280160"/>
-            <a:ext cx="2514600" cy="548640"/>
-          </a:xfrm>
-          <a:prstGeom prst="roundRect">
-            <a:avLst>
-              <a:gd name="adj" fmla="val 16667"/>
-            </a:avLst>
-          </a:prstGeom>
-          <a:solidFill>
-            <a:srgbClr val="D4824A"/>
-          </a:solidFill>
-          <a:ln w="12700">
-            <a:solidFill>
-              <a:srgbClr val="D4824A"/>
-            </a:solidFill>
-            <a:prstDash val="solid"/>
-          </a:ln>
-        </p:spPr>
-      </p:sp>
-      <p:sp>
-        <p:nvSpPr>
-          <p:cNvPr id="10" name="Text 8"/>
-          <p:cNvSpPr txBox="1"/>
-          <p:nvPr/>
-        </p:nvSpPr>
-        <p:spPr>
-          <a:xfrm>
-            <a:off x="3314700" y="1280160"/>
-            <a:ext cx="2514600" cy="548640"/>
-          </a:xfrm>
-          <a:prstGeom prst="rect">
-            <a:avLst/>
-          </a:prstGeom>
-          <a:noFill/>
-          <a:ln/>
-        </p:spPr>
-        <p:txBody>
-          <a:bodyPr wrap="square" lIns="0" tIns="0" rIns="0" bIns="0" rtlCol="0" anchor="ctr"/>
-          <a:lstStyle/>
-          <a:p>
-            <a:pPr marL="0" indent="0" algn="ctr">
-              <a:buNone/>
-            </a:pPr>
-            <a:r>
-              <a:rPr lang="en-US" sz="1400" b="1" dirty="0">
-                <a:solidFill>
-                  <a:srgbClr val="FFFFFF"/>
-                </a:solidFill>
-                <a:latin typeface="Consolas" pitchFamily="34" charset="0"/>
-                <a:ea typeface="Consolas" pitchFamily="34" charset="-122"/>
-                <a:cs typeface="Consolas" pitchFamily="34" charset="-120"/>
-              </a:rPr>
-              <a:t>dspy.ChainOfThought</a:t>
-            </a:r>
-            <a:endParaRPr lang="en-US" sz="1400" dirty="0"/>
-          </a:p>
-        </p:txBody>
-      </p:sp>
-      <p:sp>
-        <p:nvSpPr>
-          <p:cNvPr id="11" name="Text 9"/>
-          <p:cNvSpPr txBox="1"/>
-          <p:nvPr/>
-        </p:nvSpPr>
-        <p:spPr>
-          <a:xfrm>
-            <a:off x="3515868" y="1965960"/>
-            <a:ext cx="2112264" cy="1554480"/>
-          </a:xfrm>
-          <a:prstGeom prst="rect">
-            <a:avLst/>
-          </a:prstGeom>
-          <a:noFill/>
-          <a:ln/>
-        </p:spPr>
-        <p:txBody>
-          <a:bodyPr wrap="square" lIns="0" tIns="0" rIns="0" bIns="0" rtlCol="0" anchor="t"/>
-          <a:lstStyle/>
-          <a:p>
-            <a:pPr marL="0" indent="0">
-              <a:buNone/>
-            </a:pPr>
-            <a:r>
-              <a:rPr lang="en-US" sz="950" b="1" kern="0" spc="200" dirty="0">
-                <a:solidFill>
-                  <a:srgbClr val="D4824A"/>
-                </a:solidFill>
-              </a:rPr>
-              <a:t>HOW</a:t>
-            </a:r>
-            <a:endParaRPr lang="en-US" sz="950" dirty="0"/>
-          </a:p>
-          <a:p>
-            <a:pPr marL="0" indent="0">
-              <a:buNone/>
-            </a:pPr>
-            <a:r>
-              <a:rPr lang="en-US" sz="1400" dirty="0">
-                <a:solidFill>
-                  <a:srgbClr val="1B2A4A"/>
-                </a:solidFill>
-              </a:rPr>
-              <a:t>Reasons first, then answers</a:t>
-            </a:r>
-            <a:endParaRPr lang="en-US" sz="950" dirty="0"/>
-          </a:p>
-          <a:p>
-            <a:pPr marL="0" indent="0">
-              <a:buNone/>
-            </a:pPr>
-            <a:r>
-              <a:rPr lang="en-US" sz="600" dirty="0">
-                <a:solidFill>
-                  <a:srgbClr val="000000"/>
-                </a:solidFill>
-              </a:rPr>
-              <a:t> </a:t>
-            </a:r>
-            <a:endParaRPr lang="en-US" sz="950" dirty="0"/>
-          </a:p>
-          <a:p>
-            <a:pPr marL="0" indent="0">
-              <a:buNone/>
-            </a:pPr>
-            <a:r>
-              <a:rPr lang="en-US" sz="950" b="1" kern="0" spc="200" dirty="0">
-                <a:solidFill>
-                  <a:srgbClr val="D4824A"/>
-                </a:solidFill>
-              </a:rPr>
-              <a:t>BEST FOR</a:t>
-            </a:r>
-            <a:endParaRPr lang="en-US" sz="950" dirty="0"/>
-          </a:p>
-          <a:p>
-            <a:pPr marL="0" indent="0">
-              <a:buNone/>
-            </a:pPr>
-            <a:r>
-              <a:rPr lang="en-US" sz="1400" dirty="0">
-                <a:solidFill>
-                  <a:srgbClr val="1B2A4A"/>
-                </a:solidFill>
-              </a:rPr>
-              <a:t>Multi-step reasoning, math</a:t>
-            </a:r>
-            <a:endParaRPr lang="en-US" sz="950" dirty="0"/>
-          </a:p>
-        </p:txBody>
-      </p:sp>
-      <p:sp>
-        <p:nvSpPr>
-          <p:cNvPr id="12" name="Shape 10"/>
-          <p:cNvSpPr/>
-          <p:nvPr/>
-        </p:nvSpPr>
-        <p:spPr>
-          <a:xfrm>
-            <a:off x="6126480" y="1280160"/>
-            <a:ext cx="2514600" cy="2331720"/>
-          </a:xfrm>
-          <a:prstGeom prst="roundRect">
-            <a:avLst>
-              <a:gd name="adj" fmla="val 3922"/>
-            </a:avLst>
-          </a:prstGeom>
-          <a:solidFill>
-            <a:srgbClr val="F4F6F9"/>
-          </a:solidFill>
-          <a:ln w="12700">
-            <a:solidFill>
-              <a:srgbClr val="F4F6F9"/>
-            </a:solidFill>
-            <a:prstDash val="solid"/>
-          </a:ln>
-        </p:spPr>
-      </p:sp>
-      <p:sp>
-        <p:nvSpPr>
-          <p:cNvPr id="13" name="Shape 11"/>
-          <p:cNvSpPr/>
-          <p:nvPr/>
-        </p:nvSpPr>
-        <p:spPr>
-          <a:xfrm>
-            <a:off x="6126480" y="1280160"/>
-            <a:ext cx="2514600" cy="548640"/>
-          </a:xfrm>
-          <a:prstGeom prst="roundRect">
-            <a:avLst>
-              <a:gd name="adj" fmla="val 16667"/>
-            </a:avLst>
-          </a:prstGeom>
-          <a:solidFill>
-            <a:srgbClr val="1B2A4A"/>
-          </a:solidFill>
-          <a:ln w="12700">
-            <a:solidFill>
-              <a:srgbClr val="1B2A4A"/>
-            </a:solidFill>
-            <a:prstDash val="solid"/>
-          </a:ln>
-        </p:spPr>
-      </p:sp>
-      <p:sp>
-        <p:nvSpPr>
-          <p:cNvPr id="14" name="Text 12"/>
-          <p:cNvSpPr txBox="1"/>
-          <p:nvPr/>
-        </p:nvSpPr>
-        <p:spPr>
-          <a:xfrm>
-            <a:off x="6126480" y="1280160"/>
-            <a:ext cx="2514600" cy="548640"/>
-          </a:xfrm>
-          <a:prstGeom prst="rect">
-            <a:avLst/>
-          </a:prstGeom>
-          <a:noFill/>
-          <a:ln/>
-        </p:spPr>
-        <p:txBody>
-          <a:bodyPr wrap="square" lIns="0" tIns="0" rIns="0" bIns="0" rtlCol="0" anchor="ctr"/>
-          <a:lstStyle/>
-          <a:p>
-            <a:pPr marL="0" indent="0" algn="ctr">
-              <a:buNone/>
-            </a:pPr>
-            <a:r>
-              <a:rPr lang="en-US" sz="1400" b="1" dirty="0">
-                <a:solidFill>
-                  <a:srgbClr val="FFFFFF"/>
-                </a:solidFill>
-                <a:latin typeface="Consolas" pitchFamily="34" charset="0"/>
-                <a:ea typeface="Consolas" pitchFamily="34" charset="-122"/>
-                <a:cs typeface="Consolas" pitchFamily="34" charset="-120"/>
-              </a:rPr>
-              <a:t>dspy.ReAct</a:t>
-            </a:r>
-            <a:endParaRPr lang="en-US" sz="1400" dirty="0"/>
-          </a:p>
-        </p:txBody>
-      </p:sp>
-      <p:sp>
-        <p:nvSpPr>
-          <p:cNvPr id="15" name="Text 13"/>
-          <p:cNvSpPr txBox="1"/>
-          <p:nvPr/>
-        </p:nvSpPr>
-        <p:spPr>
-          <a:xfrm>
-            <a:off x="6327648" y="1965960"/>
-            <a:ext cx="2112264" cy="1554480"/>
-          </a:xfrm>
-          <a:prstGeom prst="rect">
-            <a:avLst/>
-          </a:prstGeom>
-          <a:noFill/>
-          <a:ln/>
-        </p:spPr>
-        <p:txBody>
-          <a:bodyPr wrap="square" lIns="0" tIns="0" rIns="0" bIns="0" rtlCol="0" anchor="t"/>
-          <a:lstStyle/>
-          <a:p>
-            <a:pPr marL="0" indent="0">
-              <a:buNone/>
-            </a:pPr>
-            <a:r>
-              <a:rPr lang="en-US" sz="950" b="1" kern="0" spc="200" dirty="0">
-                <a:solidFill>
-                  <a:srgbClr val="D4824A"/>
-                </a:solidFill>
-              </a:rPr>
-              <a:t>HOW</a:t>
-            </a:r>
-            <a:endParaRPr lang="en-US" sz="950" dirty="0"/>
-          </a:p>
-          <a:p>
-            <a:pPr marL="0" indent="0">
-              <a:buNone/>
-            </a:pPr>
-            <a:r>
-              <a:rPr lang="en-US" sz="1400" dirty="0">
-                <a:solidFill>
-                  <a:srgbClr val="1B2A4A"/>
-                </a:solidFill>
-              </a:rPr>
-              <a:t>Thought → Action → Observation loop</a:t>
-            </a:r>
-            <a:endParaRPr lang="en-US" sz="950" dirty="0"/>
-          </a:p>
-          <a:p>
-            <a:pPr marL="0" indent="0">
-              <a:buNone/>
-            </a:pPr>
-            <a:r>
-              <a:rPr lang="en-US" sz="600" dirty="0">
-                <a:solidFill>
-                  <a:srgbClr val="000000"/>
-                </a:solidFill>
-              </a:rPr>
-              <a:t> </a:t>
-            </a:r>
-            <a:endParaRPr lang="en-US" sz="950" dirty="0"/>
-          </a:p>
-          <a:p>
-            <a:pPr marL="0" indent="0">
-              <a:buNone/>
-            </a:pPr>
-            <a:r>
-              <a:rPr lang="en-US" sz="950" b="1" kern="0" spc="200" dirty="0">
-                <a:solidFill>
-                  <a:srgbClr val="D4824A"/>
-                </a:solidFill>
-              </a:rPr>
-              <a:t>BEST FOR</a:t>
-            </a:r>
-            <a:endParaRPr lang="en-US" sz="950" dirty="0"/>
-          </a:p>
-          <a:p>
-            <a:pPr marL="0" indent="0">
-              <a:buNone/>
-            </a:pPr>
-            <a:r>
-              <a:rPr lang="en-US" sz="1400" dirty="0">
-                <a:solidFill>
-                  <a:srgbClr val="1B2A4A"/>
-                </a:solidFill>
-              </a:rPr>
-              <a:t>Agents that use tools</a:t>
-            </a:r>
-            <a:endParaRPr lang="en-US" sz="950" dirty="0"/>
-          </a:p>
-        </p:txBody>
-      </p:sp>
-      <p:sp>
-        <p:nvSpPr>
-          <p:cNvPr id="16" name="Shape 14"/>
-          <p:cNvSpPr/>
-          <p:nvPr/>
-        </p:nvSpPr>
-        <p:spPr>
-          <a:xfrm>
-            <a:off x="502920" y="3840480"/>
-            <a:ext cx="8138160" cy="594360"/>
-          </a:xfrm>
-          <a:prstGeom prst="roundRect">
-            <a:avLst>
-              <a:gd name="adj" fmla="val 12308"/>
-            </a:avLst>
-          </a:prstGeom>
-          <a:solidFill>
-            <a:srgbClr val="FBEFE6"/>
-          </a:solidFill>
-          <a:ln w="12700">
-            <a:solidFill>
-              <a:srgbClr val="FBEFE6"/>
-            </a:solidFill>
-            <a:prstDash val="solid"/>
-          </a:ln>
-        </p:spPr>
-      </p:sp>
-      <p:sp>
-        <p:nvSpPr>
-          <p:cNvPr id="17" name="Text 15"/>
-          <p:cNvSpPr txBox="1"/>
-          <p:nvPr/>
-        </p:nvSpPr>
-        <p:spPr>
-          <a:xfrm>
-            <a:off x="667512" y="3840480"/>
-            <a:ext cx="7808976" cy="594360"/>
-          </a:xfrm>
-          <a:prstGeom prst="rect">
-            <a:avLst/>
-          </a:prstGeom>
-          <a:noFill/>
-          <a:ln/>
-        </p:spPr>
-        <p:txBody>
-          <a:bodyPr wrap="square" lIns="0" tIns="0" rIns="0" bIns="0" rtlCol="0" anchor="ctr"/>
-          <a:lstStyle/>
-          <a:p>
-            <a:pPr marL="0" indent="0">
-              <a:buNone/>
-            </a:pPr>
-            <a:r>
-              <a:rPr lang="en-US" sz="1000" b="1" kern="0" spc="200" dirty="0">
-                <a:solidFill>
-                  <a:srgbClr val="D4824A"/>
-                </a:solidFill>
-              </a:rPr>
-              <a:t>KEY POINT  </a:t>
-            </a:r>
-            <a:r>
-              <a:rPr lang="en-US" sz="1300" dirty="0">
-                <a:solidFill>
-                  <a:srgbClr val="1B2A4A"/>
-                </a:solidFill>
-              </a:rPr>
-              <a:t>Same Signature, three strategies. Change one line to change how the model works.</a:t>
-            </a:r>
-            <a:endParaRPr lang="en-US" sz="1000" dirty="0"/>
-          </a:p>
-        </p:txBody>
-      </p:sp>
-      <p:sp>
-        <p:nvSpPr>
-          <p:cNvPr id="25" name="Slide Number Placeholder 0"/>
-          <p:cNvSpPr>
-            <a:spLocks noGrp="1"/>
-          </p:cNvSpPr>
-          <p:nvPr>
-            <p:ph type="sldNum" sz="quarter" idx="4294967295"/>
-          </p:nvPr>
-        </p:nvSpPr>
-        <p:spPr>
-          <a:xfrm>
-            <a:off x="8229600" y="4800600"/>
-            <a:ext cx="411480" cy="228600"/>
-          </a:xfrm>
-          <a:prstGeom prst="rect">
-            <a:avLst/>
-          </a:prstGeom>
-          <a:extLst>
-            <a:ext uri="{C572A759-6A51-4108-AA02-DFA0A04FC94B}">
-              <ma14:wrappingTextBoxFlag xmlns:ma14="http://schemas.microsoft.com/office/mac/drawingml/2011/main" xmlns="" val="0"/>
+              <ma14:wrappingTextBoxFlag xmlns="" xmlns:ma14="http://schemas.microsoft.com/office/mac/drawingml/2011/main" val="0"/>
             </a:ext>
           </a:extLst>
         </p:spPr>

</xml_diff>